<commit_message>
3/12: add two pptx
</commit_message>
<xml_diff>
--- a/experiment_report_0312.pptx
+++ b/experiment_report_0312.pptx
@@ -26,6 +26,7 @@
     <p:sldId id="271" r:id="rId21"/>
     <p:sldId id="272" r:id="rId22"/>
     <p:sldId id="273" r:id="rId23"/>
+    <p:sldId id="274" r:id="rId24"/>
   </p:sldIdLst>
   <p:sldSz cy="5143500" cx="9144000"/>
   <p:notesSz cx="5143500" cy="9144000"/>
@@ -260,7 +261,7 @@
   </p:defaultTextStyle>
   <p:extLst>
     <p:ext uri="GoogleSlidesCustomDataVersion2">
-      <go:slidesCustomData xmlns:go="http://customooxmlschemas.google.com/" r:id="rId24" roundtripDataSignature="AMtx7miMUnE6pThEZ5sP/tCtg9Piw53tWw=="/>
+      <go:slidesCustomData xmlns:go="http://customooxmlschemas.google.com/" r:id="rId25" roundtripDataSignature="AMtx7mitsHcCKm32b/sCEX/VgMqx9Iejlg=="/>
     </p:ext>
   </p:extLst>
 </p:presentation>
@@ -1596,7 +1597,7 @@
   <p:cSld>
     <p:spTree>
       <p:nvGrpSpPr>
-        <p:cNvPr id="106" name="Shape 106"/>
+        <p:cNvPr id="97" name="Shape 97"/>
         <p:cNvGrpSpPr/>
         <p:nvPr/>
       </p:nvGrpSpPr>
@@ -1610,7 +1611,7 @@
       </p:grpSpPr>
       <p:sp>
         <p:nvSpPr>
-          <p:cNvPr id="107" name="Google Shape;107;p11:notes"/>
+          <p:cNvPr id="98" name="Google Shape;98;g395f996db06_0_0:notes"/>
           <p:cNvSpPr/>
           <p:nvPr>
             <p:ph idx="2" type="sldImg"/>
@@ -1655,7 +1656,7 @@
       </p:sp>
       <p:sp>
         <p:nvSpPr>
-          <p:cNvPr id="108" name="Google Shape;108;p11:notes"/>
+          <p:cNvPr id="99" name="Google Shape;99;g395f996db06_0_0:notes"/>
           <p:cNvSpPr txBox="1"/>
           <p:nvPr>
             <p:ph idx="1" type="body"/>
@@ -1664,7 +1665,7 @@
         <p:spPr>
           <a:xfrm>
             <a:off x="685800" y="4400550"/>
-            <a:ext cx="5486400" cy="3600450"/>
+            <a:ext cx="5486400" cy="3600600"/>
           </a:xfrm>
           <a:prstGeom prst="rect">
             <a:avLst/>
@@ -1698,7 +1699,7 @@
       </p:sp>
       <p:sp>
         <p:nvSpPr>
-          <p:cNvPr id="109" name="Google Shape;109;p11:notes"/>
+          <p:cNvPr id="100" name="Google Shape;100;g395f996db06_0_0:notes"/>
           <p:cNvSpPr txBox="1"/>
           <p:nvPr>
             <p:ph idx="12" type="sldNum"/>
@@ -1707,7 +1708,7 @@
         <p:spPr>
           <a:xfrm>
             <a:off x="3884613" y="8685213"/>
-            <a:ext cx="2971800" cy="458787"/>
+            <a:ext cx="2971800" cy="458700"/>
           </a:xfrm>
           <a:prstGeom prst="rect">
             <a:avLst/>
@@ -1753,7 +1754,7 @@
   <p:cSld>
     <p:spTree>
       <p:nvGrpSpPr>
-        <p:cNvPr id="113" name="Shape 113"/>
+        <p:cNvPr id="114" name="Shape 114"/>
         <p:cNvGrpSpPr/>
         <p:nvPr/>
       </p:nvGrpSpPr>
@@ -1767,7 +1768,7 @@
       </p:grpSpPr>
       <p:sp>
         <p:nvSpPr>
-          <p:cNvPr id="114" name="Google Shape;114;p12:notes"/>
+          <p:cNvPr id="115" name="Google Shape;115;p11:notes"/>
           <p:cNvSpPr/>
           <p:nvPr>
             <p:ph idx="2" type="sldImg"/>
@@ -1812,7 +1813,7 @@
       </p:sp>
       <p:sp>
         <p:nvSpPr>
-          <p:cNvPr id="115" name="Google Shape;115;p12:notes"/>
+          <p:cNvPr id="116" name="Google Shape;116;p11:notes"/>
           <p:cNvSpPr txBox="1"/>
           <p:nvPr>
             <p:ph idx="1" type="body"/>
@@ -1855,7 +1856,7 @@
       </p:sp>
       <p:sp>
         <p:nvSpPr>
-          <p:cNvPr id="116" name="Google Shape;116;p12:notes"/>
+          <p:cNvPr id="117" name="Google Shape;117;p11:notes"/>
           <p:cNvSpPr txBox="1"/>
           <p:nvPr>
             <p:ph idx="12" type="sldNum"/>
@@ -1910,7 +1911,7 @@
   <p:cSld>
     <p:spTree>
       <p:nvGrpSpPr>
-        <p:cNvPr id="123" name="Shape 123"/>
+        <p:cNvPr id="121" name="Shape 121"/>
         <p:cNvGrpSpPr/>
         <p:nvPr/>
       </p:nvGrpSpPr>
@@ -1924,7 +1925,7 @@
       </p:grpSpPr>
       <p:sp>
         <p:nvSpPr>
-          <p:cNvPr id="124" name="Google Shape;124;p13:notes"/>
+          <p:cNvPr id="122" name="Google Shape;122;p12:notes"/>
           <p:cNvSpPr/>
           <p:nvPr>
             <p:ph idx="2" type="sldImg"/>
@@ -1969,7 +1970,7 @@
       </p:sp>
       <p:sp>
         <p:nvSpPr>
-          <p:cNvPr id="125" name="Google Shape;125;p13:notes"/>
+          <p:cNvPr id="123" name="Google Shape;123;p12:notes"/>
           <p:cNvSpPr txBox="1"/>
           <p:nvPr>
             <p:ph idx="1" type="body"/>
@@ -2012,7 +2013,7 @@
       </p:sp>
       <p:sp>
         <p:nvSpPr>
-          <p:cNvPr id="126" name="Google Shape;126;p13:notes"/>
+          <p:cNvPr id="124" name="Google Shape;124;p12:notes"/>
           <p:cNvSpPr txBox="1"/>
           <p:nvPr>
             <p:ph idx="12" type="sldNum"/>
@@ -2081,7 +2082,7 @@
       </p:grpSpPr>
       <p:sp>
         <p:nvSpPr>
-          <p:cNvPr id="132" name="Google Shape;132;p14:notes"/>
+          <p:cNvPr id="132" name="Google Shape;132;g395f996db06_0_49:notes"/>
           <p:cNvSpPr/>
           <p:nvPr>
             <p:ph idx="2" type="sldImg"/>
@@ -2126,7 +2127,7 @@
       </p:sp>
       <p:sp>
         <p:nvSpPr>
-          <p:cNvPr id="133" name="Google Shape;133;p14:notes"/>
+          <p:cNvPr id="133" name="Google Shape;133;g395f996db06_0_49:notes"/>
           <p:cNvSpPr txBox="1"/>
           <p:nvPr>
             <p:ph idx="1" type="body"/>
@@ -2135,7 +2136,7 @@
         <p:spPr>
           <a:xfrm>
             <a:off x="685800" y="4400550"/>
-            <a:ext cx="5486400" cy="3600450"/>
+            <a:ext cx="5486400" cy="3600600"/>
           </a:xfrm>
           <a:prstGeom prst="rect">
             <a:avLst/>
@@ -2169,7 +2170,7 @@
       </p:sp>
       <p:sp>
         <p:nvSpPr>
-          <p:cNvPr id="134" name="Google Shape;134;p14:notes"/>
+          <p:cNvPr id="134" name="Google Shape;134;g395f996db06_0_49:notes"/>
           <p:cNvSpPr txBox="1"/>
           <p:nvPr>
             <p:ph idx="12" type="sldNum"/>
@@ -2178,7 +2179,7 @@
         <p:spPr>
           <a:xfrm>
             <a:off x="3884613" y="8685213"/>
-            <a:ext cx="2971800" cy="458787"/>
+            <a:ext cx="2971800" cy="458700"/>
           </a:xfrm>
           <a:prstGeom prst="rect">
             <a:avLst/>
@@ -2224,7 +2225,7 @@
   <p:cSld>
     <p:spTree>
       <p:nvGrpSpPr>
-        <p:cNvPr id="141" name="Shape 141"/>
+        <p:cNvPr id="138" name="Shape 138"/>
         <p:cNvGrpSpPr/>
         <p:nvPr/>
       </p:nvGrpSpPr>
@@ -2238,7 +2239,7 @@
       </p:grpSpPr>
       <p:sp>
         <p:nvSpPr>
-          <p:cNvPr id="142" name="Google Shape;142;p15:notes"/>
+          <p:cNvPr id="139" name="Google Shape;139;p13:notes"/>
           <p:cNvSpPr/>
           <p:nvPr>
             <p:ph idx="2" type="sldImg"/>
@@ -2283,7 +2284,7 @@
       </p:sp>
       <p:sp>
         <p:nvSpPr>
-          <p:cNvPr id="143" name="Google Shape;143;p15:notes"/>
+          <p:cNvPr id="140" name="Google Shape;140;p13:notes"/>
           <p:cNvSpPr txBox="1"/>
           <p:nvPr>
             <p:ph idx="1" type="body"/>
@@ -2326,7 +2327,7 @@
       </p:sp>
       <p:sp>
         <p:nvSpPr>
-          <p:cNvPr id="144" name="Google Shape;144;p15:notes"/>
+          <p:cNvPr id="141" name="Google Shape;141;p13:notes"/>
           <p:cNvSpPr txBox="1"/>
           <p:nvPr>
             <p:ph idx="12" type="sldNum"/>
@@ -2381,7 +2382,7 @@
   <p:cSld>
     <p:spTree>
       <p:nvGrpSpPr>
-        <p:cNvPr id="158" name="Shape 158"/>
+        <p:cNvPr id="146" name="Shape 146"/>
         <p:cNvGrpSpPr/>
         <p:nvPr/>
       </p:nvGrpSpPr>
@@ -2395,7 +2396,7 @@
       </p:grpSpPr>
       <p:sp>
         <p:nvSpPr>
-          <p:cNvPr id="159" name="Google Shape;159;p16:notes"/>
+          <p:cNvPr id="147" name="Google Shape;147;p14:notes"/>
           <p:cNvSpPr/>
           <p:nvPr>
             <p:ph idx="2" type="sldImg"/>
@@ -2440,7 +2441,7 @@
       </p:sp>
       <p:sp>
         <p:nvSpPr>
-          <p:cNvPr id="160" name="Google Shape;160;p16:notes"/>
+          <p:cNvPr id="148" name="Google Shape;148;p14:notes"/>
           <p:cNvSpPr txBox="1"/>
           <p:nvPr>
             <p:ph idx="1" type="body"/>
@@ -2483,7 +2484,7 @@
       </p:sp>
       <p:sp>
         <p:nvSpPr>
-          <p:cNvPr id="161" name="Google Shape;161;p16:notes"/>
+          <p:cNvPr id="149" name="Google Shape;149;p14:notes"/>
           <p:cNvSpPr txBox="1"/>
           <p:nvPr>
             <p:ph idx="12" type="sldNum"/>
@@ -2538,7 +2539,7 @@
   <p:cSld>
     <p:spTree>
       <p:nvGrpSpPr>
-        <p:cNvPr id="166" name="Shape 166"/>
+        <p:cNvPr id="156" name="Shape 156"/>
         <p:cNvGrpSpPr/>
         <p:nvPr/>
       </p:nvGrpSpPr>
@@ -2552,7 +2553,7 @@
       </p:grpSpPr>
       <p:sp>
         <p:nvSpPr>
-          <p:cNvPr id="167" name="Google Shape;167;p17:notes"/>
+          <p:cNvPr id="157" name="Google Shape;157;p15:notes"/>
           <p:cNvSpPr/>
           <p:nvPr>
             <p:ph idx="2" type="sldImg"/>
@@ -2597,7 +2598,7 @@
       </p:sp>
       <p:sp>
         <p:nvSpPr>
-          <p:cNvPr id="168" name="Google Shape;168;p17:notes"/>
+          <p:cNvPr id="158" name="Google Shape;158;p15:notes"/>
           <p:cNvSpPr txBox="1"/>
           <p:nvPr>
             <p:ph idx="1" type="body"/>
@@ -2640,7 +2641,7 @@
       </p:sp>
       <p:sp>
         <p:nvSpPr>
-          <p:cNvPr id="169" name="Google Shape;169;p17:notes"/>
+          <p:cNvPr id="159" name="Google Shape;159;p15:notes"/>
           <p:cNvSpPr txBox="1"/>
           <p:nvPr>
             <p:ph idx="12" type="sldNum"/>
@@ -2695,7 +2696,7 @@
   <p:cSld>
     <p:spTree>
       <p:nvGrpSpPr>
-        <p:cNvPr id="177" name="Shape 177"/>
+        <p:cNvPr id="173" name="Shape 173"/>
         <p:cNvGrpSpPr/>
         <p:nvPr/>
       </p:nvGrpSpPr>
@@ -2709,7 +2710,7 @@
       </p:grpSpPr>
       <p:sp>
         <p:nvSpPr>
-          <p:cNvPr id="178" name="Google Shape;178;p18:notes"/>
+          <p:cNvPr id="174" name="Google Shape;174;p16:notes"/>
           <p:cNvSpPr/>
           <p:nvPr>
             <p:ph idx="2" type="sldImg"/>
@@ -2754,7 +2755,7 @@
       </p:sp>
       <p:sp>
         <p:nvSpPr>
-          <p:cNvPr id="179" name="Google Shape;179;p18:notes"/>
+          <p:cNvPr id="175" name="Google Shape;175;p16:notes"/>
           <p:cNvSpPr txBox="1"/>
           <p:nvPr>
             <p:ph idx="1" type="body"/>
@@ -2797,7 +2798,7 @@
       </p:sp>
       <p:sp>
         <p:nvSpPr>
-          <p:cNvPr id="180" name="Google Shape;180;p18:notes"/>
+          <p:cNvPr id="176" name="Google Shape;176;p16:notes"/>
           <p:cNvSpPr txBox="1"/>
           <p:nvPr>
             <p:ph idx="12" type="sldNum"/>
@@ -2852,7 +2853,7 @@
   <p:cSld>
     <p:spTree>
       <p:nvGrpSpPr>
-        <p:cNvPr id="186" name="Shape 186"/>
+        <p:cNvPr id="181" name="Shape 181"/>
         <p:cNvGrpSpPr/>
         <p:nvPr/>
       </p:nvGrpSpPr>
@@ -2866,7 +2867,7 @@
       </p:grpSpPr>
       <p:sp>
         <p:nvSpPr>
-          <p:cNvPr id="187" name="Google Shape;187;p19:notes"/>
+          <p:cNvPr id="182" name="Google Shape;182;p17:notes"/>
           <p:cNvSpPr/>
           <p:nvPr>
             <p:ph idx="2" type="sldImg"/>
@@ -2911,7 +2912,7 @@
       </p:sp>
       <p:sp>
         <p:nvSpPr>
-          <p:cNvPr id="188" name="Google Shape;188;p19:notes"/>
+          <p:cNvPr id="183" name="Google Shape;183;p17:notes"/>
           <p:cNvSpPr txBox="1"/>
           <p:nvPr>
             <p:ph idx="1" type="body"/>
@@ -2954,7 +2955,164 @@
       </p:sp>
       <p:sp>
         <p:nvSpPr>
-          <p:cNvPr id="189" name="Google Shape;189;p19:notes"/>
+          <p:cNvPr id="184" name="Google Shape;184;p17:notes"/>
+          <p:cNvSpPr txBox="1"/>
+          <p:nvPr>
+            <p:ph idx="12" type="sldNum"/>
+          </p:nvPr>
+        </p:nvSpPr>
+        <p:spPr>
+          <a:xfrm>
+            <a:off x="3884613" y="8685213"/>
+            <a:ext cx="2971800" cy="458787"/>
+          </a:xfrm>
+          <a:prstGeom prst="rect">
+            <a:avLst/>
+          </a:prstGeom>
+          <a:noFill/>
+          <a:ln>
+            <a:noFill/>
+          </a:ln>
+        </p:spPr>
+        <p:txBody>
+          <a:bodyPr anchorCtr="0" anchor="b" bIns="45700" lIns="91425" spcFirstLastPara="1" rIns="91425" wrap="square" tIns="45700">
+            <a:noAutofit/>
+          </a:bodyPr>
+          <a:lstStyle/>
+          <a:p>
+            <a:pPr indent="0" lvl="0" marL="0" rtl="0" algn="r">
+              <a:spcBef>
+                <a:spcPts val="0"/>
+              </a:spcBef>
+              <a:spcAft>
+                <a:spcPts val="0"/>
+              </a:spcAft>
+              <a:buNone/>
+            </a:pPr>
+            <a:fld id="{00000000-1234-1234-1234-123412341234}" type="slidenum">
+              <a:rPr lang="en-US"/>
+              <a:t>‹#›</a:t>
+            </a:fld>
+            <a:endParaRPr/>
+          </a:p>
+        </p:txBody>
+      </p:sp>
+    </p:spTree>
+  </p:cSld>
+  <p:clrMapOvr>
+    <a:masterClrMapping/>
+  </p:clrMapOvr>
+</p:notes>
+</file>
+
+<file path=ppt/notesSlides/notesSlide19.xml><?xml version="1.0" encoding="utf-8"?>
+<p:notes xmlns:a="http://schemas.openxmlformats.org/drawingml/2006/main" xmlns:r="http://schemas.openxmlformats.org/officeDocument/2006/relationships" xmlns:mc="http://schemas.openxmlformats.org/markup-compatibility/2006" xmlns:mv="urn:schemas-microsoft-com:mac:vml" xmlns:p="http://schemas.openxmlformats.org/presentationml/2006/main" xmlns:c="http://schemas.openxmlformats.org/drawingml/2006/chart" xmlns:dgm="http://schemas.openxmlformats.org/drawingml/2006/diagram" xmlns:o="urn:schemas-microsoft-com:office:office" xmlns:v="urn:schemas-microsoft-com:vml" xmlns:pvml="urn:schemas-microsoft-com:office:powerpoint" xmlns:com="http://schemas.openxmlformats.org/drawingml/2006/compatibility" xmlns:p14="http://schemas.microsoft.com/office/powerpoint/2010/main" xmlns:p15="http://schemas.microsoft.com/office/powerpoint/2012/main" xmlns:ahyp="http://schemas.microsoft.com/office/drawing/2018/hyperlinkcolor" showMasterPhAnim="0" showMasterSp="0">
+  <p:cSld>
+    <p:spTree>
+      <p:nvGrpSpPr>
+        <p:cNvPr id="192" name="Shape 192"/>
+        <p:cNvGrpSpPr/>
+        <p:nvPr/>
+      </p:nvGrpSpPr>
+      <p:grpSpPr>
+        <a:xfrm>
+          <a:off x="0" y="0"/>
+          <a:ext cx="0" cy="0"/>
+          <a:chOff x="0" y="0"/>
+          <a:chExt cx="0" cy="0"/>
+        </a:xfrm>
+      </p:grpSpPr>
+      <p:sp>
+        <p:nvSpPr>
+          <p:cNvPr id="193" name="Google Shape;193;p18:notes"/>
+          <p:cNvSpPr/>
+          <p:nvPr>
+            <p:ph idx="2" type="sldImg"/>
+          </p:nvPr>
+        </p:nvSpPr>
+        <p:spPr>
+          <a:xfrm>
+            <a:off x="685800" y="1143000"/>
+            <a:ext cx="5486400" cy="3086100"/>
+          </a:xfrm>
+          <a:custGeom>
+            <a:rect b="b" l="l" r="r" t="t"/>
+            <a:pathLst>
+              <a:path extrusionOk="0" h="120000" w="120000">
+                <a:moveTo>
+                  <a:pt x="0" y="0"/>
+                </a:moveTo>
+                <a:lnTo>
+                  <a:pt x="120000" y="0"/>
+                </a:lnTo>
+                <a:lnTo>
+                  <a:pt x="120000" y="120000"/>
+                </a:lnTo>
+                <a:lnTo>
+                  <a:pt x="0" y="120000"/>
+                </a:lnTo>
+                <a:close/>
+              </a:path>
+            </a:pathLst>
+          </a:custGeom>
+          <a:noFill/>
+          <a:ln cap="flat" cmpd="sng" w="12700">
+            <a:solidFill>
+              <a:srgbClr val="000000"/>
+            </a:solidFill>
+            <a:prstDash val="solid"/>
+            <a:round/>
+            <a:headEnd len="sm" w="sm" type="none"/>
+            <a:tailEnd len="sm" w="sm" type="none"/>
+          </a:ln>
+        </p:spPr>
+      </p:sp>
+      <p:sp>
+        <p:nvSpPr>
+          <p:cNvPr id="194" name="Google Shape;194;p18:notes"/>
+          <p:cNvSpPr txBox="1"/>
+          <p:nvPr>
+            <p:ph idx="1" type="body"/>
+          </p:nvPr>
+        </p:nvSpPr>
+        <p:spPr>
+          <a:xfrm>
+            <a:off x="685800" y="4400550"/>
+            <a:ext cx="5486400" cy="3600450"/>
+          </a:xfrm>
+          <a:prstGeom prst="rect">
+            <a:avLst/>
+          </a:prstGeom>
+          <a:noFill/>
+          <a:ln>
+            <a:noFill/>
+          </a:ln>
+        </p:spPr>
+        <p:txBody>
+          <a:bodyPr anchorCtr="0" anchor="t" bIns="45700" lIns="91425" spcFirstLastPara="1" rIns="91425" wrap="square" tIns="45700">
+            <a:noAutofit/>
+          </a:bodyPr>
+          <a:lstStyle/>
+          <a:p>
+            <a:pPr indent="0" lvl="0" marL="0" rtl="0" algn="l">
+              <a:spcBef>
+                <a:spcPts val="0"/>
+              </a:spcBef>
+              <a:spcAft>
+                <a:spcPts val="0"/>
+              </a:spcAft>
+              <a:buNone/>
+            </a:pPr>
+            <a:r>
+              <a:t/>
+            </a:r>
+            <a:endParaRPr/>
+          </a:p>
+        </p:txBody>
+      </p:sp>
+      <p:sp>
+        <p:nvSpPr>
+          <p:cNvPr id="195" name="Google Shape;195;p18:notes"/>
           <p:cNvSpPr txBox="1"/>
           <p:nvPr>
             <p:ph idx="12" type="sldNum"/>
@@ -3965,7 +4123,7 @@
       </p:grpSpPr>
       <p:sp>
         <p:nvSpPr>
-          <p:cNvPr id="83" name="Google Shape;83;p9:notes"/>
+          <p:cNvPr id="83" name="Google Shape;83;g395f996db06_0_36:notes"/>
           <p:cNvSpPr/>
           <p:nvPr>
             <p:ph idx="2" type="sldImg"/>
@@ -4010,7 +4168,7 @@
       </p:sp>
       <p:sp>
         <p:nvSpPr>
-          <p:cNvPr id="84" name="Google Shape;84;p9:notes"/>
+          <p:cNvPr id="84" name="Google Shape;84;g395f996db06_0_36:notes"/>
           <p:cNvSpPr txBox="1"/>
           <p:nvPr>
             <p:ph idx="1" type="body"/>
@@ -4019,7 +4177,7 @@
         <p:spPr>
           <a:xfrm>
             <a:off x="685800" y="4400550"/>
-            <a:ext cx="5486400" cy="3600450"/>
+            <a:ext cx="5486400" cy="3600600"/>
           </a:xfrm>
           <a:prstGeom prst="rect">
             <a:avLst/>
@@ -4053,7 +4211,7 @@
       </p:sp>
       <p:sp>
         <p:nvSpPr>
-          <p:cNvPr id="85" name="Google Shape;85;p9:notes"/>
+          <p:cNvPr id="85" name="Google Shape;85;g395f996db06_0_36:notes"/>
           <p:cNvSpPr txBox="1"/>
           <p:nvPr>
             <p:ph idx="12" type="sldNum"/>
@@ -4062,7 +4220,7 @@
         <p:spPr>
           <a:xfrm>
             <a:off x="3884613" y="8685213"/>
-            <a:ext cx="2971800" cy="458787"/>
+            <a:ext cx="2971800" cy="458700"/>
           </a:xfrm>
           <a:prstGeom prst="rect">
             <a:avLst/>
@@ -4122,7 +4280,7 @@
       </p:grpSpPr>
       <p:sp>
         <p:nvSpPr>
-          <p:cNvPr id="90" name="Google Shape;90;g395f996db06_0_0:notes"/>
+          <p:cNvPr id="90" name="Google Shape;90;p9:notes"/>
           <p:cNvSpPr/>
           <p:nvPr>
             <p:ph idx="2" type="sldImg"/>
@@ -4167,7 +4325,7 @@
       </p:sp>
       <p:sp>
         <p:nvSpPr>
-          <p:cNvPr id="91" name="Google Shape;91;g395f996db06_0_0:notes"/>
+          <p:cNvPr id="91" name="Google Shape;91;p9:notes"/>
           <p:cNvSpPr txBox="1"/>
           <p:nvPr>
             <p:ph idx="1" type="body"/>
@@ -4176,7 +4334,7 @@
         <p:spPr>
           <a:xfrm>
             <a:off x="685800" y="4400550"/>
-            <a:ext cx="5486400" cy="3600600"/>
+            <a:ext cx="5486400" cy="3600450"/>
           </a:xfrm>
           <a:prstGeom prst="rect">
             <a:avLst/>
@@ -4210,7 +4368,7 @@
       </p:sp>
       <p:sp>
         <p:nvSpPr>
-          <p:cNvPr id="92" name="Google Shape;92;g395f996db06_0_0:notes"/>
+          <p:cNvPr id="92" name="Google Shape;92;p9:notes"/>
           <p:cNvSpPr txBox="1"/>
           <p:nvPr>
             <p:ph idx="12" type="sldNum"/>
@@ -4219,7 +4377,7 @@
         <p:spPr>
           <a:xfrm>
             <a:off x="3884613" y="8685213"/>
-            <a:ext cx="2971800" cy="458700"/>
+            <a:ext cx="2971800" cy="458787"/>
           </a:xfrm>
           <a:prstGeom prst="rect">
             <a:avLst/>
@@ -5278,13 +5436,13 @@
     <p:bg>
       <p:bgPr>
         <a:solidFill>
-          <a:srgbClr val="FFFFFF"/>
+          <a:srgbClr val="F1F5F9"/>
         </a:solidFill>
       </p:bgPr>
     </p:bg>
     <p:spTree>
       <p:nvGrpSpPr>
-        <p:cNvPr id="110" name="Shape 110"/>
+        <p:cNvPr id="101" name="Shape 101"/>
         <p:cNvGrpSpPr/>
         <p:nvPr/>
       </p:nvGrpSpPr>
@@ -5298,7 +5456,804 @@
       </p:grpSpPr>
       <p:sp>
         <p:nvSpPr>
-          <p:cNvPr id="111" name="Google Shape;111;p11"/>
+          <p:cNvPr id="102" name="Google Shape;102;g395f996db06_0_0"/>
+          <p:cNvSpPr/>
+          <p:nvPr/>
+        </p:nvSpPr>
+        <p:spPr>
+          <a:xfrm>
+            <a:off x="457200" y="274320"/>
+            <a:ext cx="8229600" cy="640200"/>
+          </a:xfrm>
+          <a:prstGeom prst="rect">
+            <a:avLst/>
+          </a:prstGeom>
+          <a:noFill/>
+          <a:ln>
+            <a:noFill/>
+          </a:ln>
+        </p:spPr>
+        <p:txBody>
+          <a:bodyPr anchorCtr="0" anchor="ctr" bIns="0" lIns="0" spcFirstLastPara="1" rIns="0" wrap="square" tIns="0">
+            <a:noAutofit/>
+          </a:bodyPr>
+          <a:lstStyle/>
+          <a:p>
+            <a:pPr indent="0" lvl="0" marL="0" marR="0" rtl="0" algn="l">
+              <a:spcBef>
+                <a:spcPts val="0"/>
+              </a:spcBef>
+              <a:spcAft>
+                <a:spcPts val="0"/>
+              </a:spcAft>
+              <a:buClr>
+                <a:srgbClr val="1E293B"/>
+              </a:buClr>
+              <a:buSzPts val="2400"/>
+              <a:buFont typeface="Trebuchet MS"/>
+              <a:buNone/>
+            </a:pPr>
+            <a:r>
+              <a:rPr b="1" i="0" lang="en-US" sz="2400" u="none" cap="none" strike="noStrike">
+                <a:solidFill>
+                  <a:srgbClr val="1E293B"/>
+                </a:solidFill>
+                <a:latin typeface="Trebuchet MS"/>
+                <a:ea typeface="Trebuchet MS"/>
+                <a:cs typeface="Trebuchet MS"/>
+                <a:sym typeface="Trebuchet MS"/>
+              </a:rPr>
+              <a:t>DQN — Results</a:t>
+            </a:r>
+            <a:endParaRPr b="0" i="0" sz="2400" u="none" cap="none" strike="noStrike">
+              <a:solidFill>
+                <a:schemeClr val="dk1"/>
+              </a:solidFill>
+              <a:latin typeface="Calibri"/>
+              <a:ea typeface="Calibri"/>
+              <a:cs typeface="Calibri"/>
+              <a:sym typeface="Calibri"/>
+            </a:endParaRPr>
+          </a:p>
+        </p:txBody>
+      </p:sp>
+      <p:sp>
+        <p:nvSpPr>
+          <p:cNvPr id="103" name="Google Shape;103;g395f996db06_0_0"/>
+          <p:cNvSpPr/>
+          <p:nvPr/>
+        </p:nvSpPr>
+        <p:spPr>
+          <a:xfrm>
+            <a:off x="457200" y="1188720"/>
+            <a:ext cx="2560200" cy="1463100"/>
+          </a:xfrm>
+          <a:prstGeom prst="rect">
+            <a:avLst/>
+          </a:prstGeom>
+          <a:solidFill>
+            <a:srgbClr val="FFFFFF"/>
+          </a:solidFill>
+          <a:ln>
+            <a:noFill/>
+          </a:ln>
+          <a:effectLst>
+            <a:outerShdw blurRad="76200" rotWithShape="0" algn="bl" dir="8100000" dist="25400">
+              <a:srgbClr val="000000">
+                <a:alpha val="7840"/>
+              </a:srgbClr>
+            </a:outerShdw>
+          </a:effectLst>
+        </p:spPr>
+        <p:txBody>
+          <a:bodyPr anchorCtr="0" anchor="ctr" bIns="91425" lIns="91425" spcFirstLastPara="1" rIns="91425" wrap="square" tIns="91425">
+            <a:noAutofit/>
+          </a:bodyPr>
+          <a:lstStyle/>
+          <a:p>
+            <a:pPr indent="0" lvl="0" marL="0" rtl="0" algn="l">
+              <a:spcBef>
+                <a:spcPts val="0"/>
+              </a:spcBef>
+              <a:spcAft>
+                <a:spcPts val="0"/>
+              </a:spcAft>
+              <a:buNone/>
+            </a:pPr>
+            <a:r>
+              <a:t/>
+            </a:r>
+            <a:endParaRPr/>
+          </a:p>
+        </p:txBody>
+      </p:sp>
+      <p:sp>
+        <p:nvSpPr>
+          <p:cNvPr id="104" name="Google Shape;104;g395f996db06_0_0"/>
+          <p:cNvSpPr/>
+          <p:nvPr/>
+        </p:nvSpPr>
+        <p:spPr>
+          <a:xfrm>
+            <a:off x="457200" y="1325880"/>
+            <a:ext cx="2560200" cy="822900"/>
+          </a:xfrm>
+          <a:prstGeom prst="rect">
+            <a:avLst/>
+          </a:prstGeom>
+          <a:noFill/>
+          <a:ln>
+            <a:noFill/>
+          </a:ln>
+        </p:spPr>
+        <p:txBody>
+          <a:bodyPr anchorCtr="0" anchor="ctr" bIns="0" lIns="0" spcFirstLastPara="1" rIns="0" wrap="square" tIns="0">
+            <a:noAutofit/>
+          </a:bodyPr>
+          <a:lstStyle/>
+          <a:p>
+            <a:pPr indent="0" lvl="0" marL="0" marR="0" rtl="0" algn="ctr">
+              <a:spcBef>
+                <a:spcPts val="0"/>
+              </a:spcBef>
+              <a:spcAft>
+                <a:spcPts val="0"/>
+              </a:spcAft>
+              <a:buClr>
+                <a:srgbClr val="0891B2"/>
+              </a:buClr>
+              <a:buSzPts val="4400"/>
+              <a:buFont typeface="Trebuchet MS"/>
+              <a:buNone/>
+            </a:pPr>
+            <a:r>
+              <a:rPr b="1" i="0" lang="en-US" sz="4400" u="none" cap="none" strike="noStrike">
+                <a:solidFill>
+                  <a:srgbClr val="0891B2"/>
+                </a:solidFill>
+                <a:latin typeface="Trebuchet MS"/>
+                <a:ea typeface="Trebuchet MS"/>
+                <a:cs typeface="Trebuchet MS"/>
+                <a:sym typeface="Trebuchet MS"/>
+              </a:rPr>
+              <a:t>4</a:t>
+            </a:r>
+            <a:r>
+              <a:rPr b="1" lang="en-US" sz="4400">
+                <a:solidFill>
+                  <a:srgbClr val="0891B2"/>
+                </a:solidFill>
+                <a:latin typeface="Trebuchet MS"/>
+                <a:ea typeface="Trebuchet MS"/>
+                <a:cs typeface="Trebuchet MS"/>
+                <a:sym typeface="Trebuchet MS"/>
+              </a:rPr>
+              <a:t>6.0</a:t>
+            </a:r>
+            <a:r>
+              <a:rPr b="1" i="0" lang="en-US" sz="4400" u="none" cap="none" strike="noStrike">
+                <a:solidFill>
+                  <a:srgbClr val="0891B2"/>
+                </a:solidFill>
+                <a:latin typeface="Trebuchet MS"/>
+                <a:ea typeface="Trebuchet MS"/>
+                <a:cs typeface="Trebuchet MS"/>
+                <a:sym typeface="Trebuchet MS"/>
+              </a:rPr>
+              <a:t>%</a:t>
+            </a:r>
+            <a:endParaRPr b="0" i="0" sz="4400" u="none" cap="none" strike="noStrike">
+              <a:solidFill>
+                <a:schemeClr val="dk1"/>
+              </a:solidFill>
+              <a:latin typeface="Calibri"/>
+              <a:ea typeface="Calibri"/>
+              <a:cs typeface="Calibri"/>
+              <a:sym typeface="Calibri"/>
+            </a:endParaRPr>
+          </a:p>
+        </p:txBody>
+      </p:sp>
+      <p:sp>
+        <p:nvSpPr>
+          <p:cNvPr id="105" name="Google Shape;105;g395f996db06_0_0"/>
+          <p:cNvSpPr/>
+          <p:nvPr/>
+        </p:nvSpPr>
+        <p:spPr>
+          <a:xfrm>
+            <a:off x="457200" y="2148840"/>
+            <a:ext cx="2560200" cy="365700"/>
+          </a:xfrm>
+          <a:prstGeom prst="rect">
+            <a:avLst/>
+          </a:prstGeom>
+          <a:noFill/>
+          <a:ln>
+            <a:noFill/>
+          </a:ln>
+        </p:spPr>
+        <p:txBody>
+          <a:bodyPr anchorCtr="0" anchor="ctr" bIns="0" lIns="0" spcFirstLastPara="1" rIns="0" wrap="square" tIns="0">
+            <a:noAutofit/>
+          </a:bodyPr>
+          <a:lstStyle/>
+          <a:p>
+            <a:pPr indent="0" lvl="0" marL="0" marR="0" rtl="0" algn="ctr">
+              <a:spcBef>
+                <a:spcPts val="0"/>
+              </a:spcBef>
+              <a:spcAft>
+                <a:spcPts val="0"/>
+              </a:spcAft>
+              <a:buClr>
+                <a:srgbClr val="64748B"/>
+              </a:buClr>
+              <a:buSzPts val="1200"/>
+              <a:buFont typeface="Calibri"/>
+              <a:buNone/>
+            </a:pPr>
+            <a:r>
+              <a:rPr b="0" i="0" lang="en-US" sz="1200" u="none" cap="none" strike="noStrike">
+                <a:solidFill>
+                  <a:srgbClr val="64748B"/>
+                </a:solidFill>
+                <a:latin typeface="Calibri"/>
+                <a:ea typeface="Calibri"/>
+                <a:cs typeface="Calibri"/>
+                <a:sym typeface="Calibri"/>
+              </a:rPr>
+              <a:t>Conversion Rate</a:t>
+            </a:r>
+            <a:endParaRPr b="0" i="0" sz="1200" u="none" cap="none" strike="noStrike">
+              <a:solidFill>
+                <a:schemeClr val="dk1"/>
+              </a:solidFill>
+              <a:latin typeface="Calibri"/>
+              <a:ea typeface="Calibri"/>
+              <a:cs typeface="Calibri"/>
+              <a:sym typeface="Calibri"/>
+            </a:endParaRPr>
+          </a:p>
+        </p:txBody>
+      </p:sp>
+      <p:sp>
+        <p:nvSpPr>
+          <p:cNvPr id="106" name="Google Shape;106;g395f996db06_0_0"/>
+          <p:cNvSpPr/>
+          <p:nvPr/>
+        </p:nvSpPr>
+        <p:spPr>
+          <a:xfrm>
+            <a:off x="3291840" y="1188720"/>
+            <a:ext cx="2560200" cy="1463100"/>
+          </a:xfrm>
+          <a:prstGeom prst="rect">
+            <a:avLst/>
+          </a:prstGeom>
+          <a:solidFill>
+            <a:srgbClr val="FFFFFF"/>
+          </a:solidFill>
+          <a:ln>
+            <a:noFill/>
+          </a:ln>
+          <a:effectLst>
+            <a:outerShdw blurRad="76200" rotWithShape="0" algn="bl" dir="8100000" dist="25400">
+              <a:srgbClr val="000000">
+                <a:alpha val="7840"/>
+              </a:srgbClr>
+            </a:outerShdw>
+          </a:effectLst>
+        </p:spPr>
+        <p:txBody>
+          <a:bodyPr anchorCtr="0" anchor="ctr" bIns="91425" lIns="91425" spcFirstLastPara="1" rIns="91425" wrap="square" tIns="91425">
+            <a:noAutofit/>
+          </a:bodyPr>
+          <a:lstStyle/>
+          <a:p>
+            <a:pPr indent="0" lvl="0" marL="0" rtl="0" algn="l">
+              <a:spcBef>
+                <a:spcPts val="0"/>
+              </a:spcBef>
+              <a:spcAft>
+                <a:spcPts val="0"/>
+              </a:spcAft>
+              <a:buNone/>
+            </a:pPr>
+            <a:r>
+              <a:t/>
+            </a:r>
+            <a:endParaRPr/>
+          </a:p>
+        </p:txBody>
+      </p:sp>
+      <p:sp>
+        <p:nvSpPr>
+          <p:cNvPr id="107" name="Google Shape;107;g395f996db06_0_0"/>
+          <p:cNvSpPr/>
+          <p:nvPr/>
+        </p:nvSpPr>
+        <p:spPr>
+          <a:xfrm>
+            <a:off x="3291840" y="1325880"/>
+            <a:ext cx="2560200" cy="822900"/>
+          </a:xfrm>
+          <a:prstGeom prst="rect">
+            <a:avLst/>
+          </a:prstGeom>
+          <a:noFill/>
+          <a:ln>
+            <a:noFill/>
+          </a:ln>
+        </p:spPr>
+        <p:txBody>
+          <a:bodyPr anchorCtr="0" anchor="ctr" bIns="0" lIns="0" spcFirstLastPara="1" rIns="0" wrap="square" tIns="0">
+            <a:noAutofit/>
+          </a:bodyPr>
+          <a:lstStyle/>
+          <a:p>
+            <a:pPr indent="0" lvl="0" marL="0" marR="0" rtl="0" algn="ctr">
+              <a:spcBef>
+                <a:spcPts val="0"/>
+              </a:spcBef>
+              <a:spcAft>
+                <a:spcPts val="0"/>
+              </a:spcAft>
+              <a:buClr>
+                <a:srgbClr val="0891B2"/>
+              </a:buClr>
+              <a:buSzPts val="4400"/>
+              <a:buFont typeface="Trebuchet MS"/>
+              <a:buNone/>
+            </a:pPr>
+            <a:r>
+              <a:rPr b="1" i="0" lang="en-US" sz="4400" u="none" cap="none" strike="noStrike">
+                <a:solidFill>
+                  <a:srgbClr val="0891B2"/>
+                </a:solidFill>
+                <a:latin typeface="Trebuchet MS"/>
+                <a:ea typeface="Trebuchet MS"/>
+                <a:cs typeface="Trebuchet MS"/>
+                <a:sym typeface="Trebuchet MS"/>
+              </a:rPr>
+              <a:t>1.</a:t>
+            </a:r>
+            <a:r>
+              <a:rPr b="1" lang="en-US" sz="4400">
+                <a:solidFill>
+                  <a:srgbClr val="0891B2"/>
+                </a:solidFill>
+                <a:latin typeface="Trebuchet MS"/>
+                <a:ea typeface="Trebuchet MS"/>
+                <a:cs typeface="Trebuchet MS"/>
+                <a:sym typeface="Trebuchet MS"/>
+              </a:rPr>
+              <a:t>66</a:t>
+            </a:r>
+            <a:endParaRPr b="0" i="0" sz="4400" u="none" cap="none" strike="noStrike">
+              <a:solidFill>
+                <a:schemeClr val="dk1"/>
+              </a:solidFill>
+              <a:latin typeface="Calibri"/>
+              <a:ea typeface="Calibri"/>
+              <a:cs typeface="Calibri"/>
+              <a:sym typeface="Calibri"/>
+            </a:endParaRPr>
+          </a:p>
+        </p:txBody>
+      </p:sp>
+      <p:sp>
+        <p:nvSpPr>
+          <p:cNvPr id="108" name="Google Shape;108;g395f996db06_0_0"/>
+          <p:cNvSpPr/>
+          <p:nvPr/>
+        </p:nvSpPr>
+        <p:spPr>
+          <a:xfrm>
+            <a:off x="3291840" y="2148840"/>
+            <a:ext cx="2560200" cy="365700"/>
+          </a:xfrm>
+          <a:prstGeom prst="rect">
+            <a:avLst/>
+          </a:prstGeom>
+          <a:noFill/>
+          <a:ln>
+            <a:noFill/>
+          </a:ln>
+        </p:spPr>
+        <p:txBody>
+          <a:bodyPr anchorCtr="0" anchor="ctr" bIns="0" lIns="0" spcFirstLastPara="1" rIns="0" wrap="square" tIns="0">
+            <a:noAutofit/>
+          </a:bodyPr>
+          <a:lstStyle/>
+          <a:p>
+            <a:pPr indent="0" lvl="0" marL="0" marR="0" rtl="0" algn="ctr">
+              <a:spcBef>
+                <a:spcPts val="0"/>
+              </a:spcBef>
+              <a:spcAft>
+                <a:spcPts val="0"/>
+              </a:spcAft>
+              <a:buClr>
+                <a:srgbClr val="64748B"/>
+              </a:buClr>
+              <a:buSzPts val="1200"/>
+              <a:buFont typeface="Calibri"/>
+              <a:buNone/>
+            </a:pPr>
+            <a:r>
+              <a:rPr b="0" i="0" lang="en-US" sz="1200" u="none" cap="none" strike="noStrike">
+                <a:solidFill>
+                  <a:srgbClr val="64748B"/>
+                </a:solidFill>
+                <a:latin typeface="Calibri"/>
+                <a:ea typeface="Calibri"/>
+                <a:cs typeface="Calibri"/>
+                <a:sym typeface="Calibri"/>
+              </a:rPr>
+              <a:t>Avg Reward</a:t>
+            </a:r>
+            <a:endParaRPr b="0" i="0" sz="1200" u="none" cap="none" strike="noStrike">
+              <a:solidFill>
+                <a:schemeClr val="dk1"/>
+              </a:solidFill>
+              <a:latin typeface="Calibri"/>
+              <a:ea typeface="Calibri"/>
+              <a:cs typeface="Calibri"/>
+              <a:sym typeface="Calibri"/>
+            </a:endParaRPr>
+          </a:p>
+        </p:txBody>
+      </p:sp>
+      <p:sp>
+        <p:nvSpPr>
+          <p:cNvPr id="109" name="Google Shape;109;g395f996db06_0_0"/>
+          <p:cNvSpPr/>
+          <p:nvPr/>
+        </p:nvSpPr>
+        <p:spPr>
+          <a:xfrm>
+            <a:off x="457200" y="3017520"/>
+            <a:ext cx="7315200" cy="365700"/>
+          </a:xfrm>
+          <a:prstGeom prst="rect">
+            <a:avLst/>
+          </a:prstGeom>
+          <a:noFill/>
+          <a:ln>
+            <a:noFill/>
+          </a:ln>
+        </p:spPr>
+        <p:txBody>
+          <a:bodyPr anchorCtr="0" anchor="ctr" bIns="45700" lIns="91425" spcFirstLastPara="1" rIns="91425" wrap="square" tIns="45700">
+            <a:noAutofit/>
+          </a:bodyPr>
+          <a:lstStyle/>
+          <a:p>
+            <a:pPr indent="0" lvl="0" marL="0" marR="0" rtl="0" algn="l">
+              <a:spcBef>
+                <a:spcPts val="0"/>
+              </a:spcBef>
+              <a:spcAft>
+                <a:spcPts val="0"/>
+              </a:spcAft>
+              <a:buClr>
+                <a:srgbClr val="64748B"/>
+              </a:buClr>
+              <a:buSzPts val="1100"/>
+              <a:buFont typeface="Calibri"/>
+              <a:buNone/>
+            </a:pPr>
+            <a:r>
+              <a:rPr b="0" i="1" lang="en-US" sz="1100" u="none" cap="none" strike="noStrike">
+                <a:solidFill>
+                  <a:srgbClr val="64748B"/>
+                </a:solidFill>
+                <a:latin typeface="Calibri"/>
+                <a:ea typeface="Calibri"/>
+                <a:cs typeface="Calibri"/>
+                <a:sym typeface="Calibri"/>
+              </a:rPr>
+              <a:t>Evaluated over 1,000 episodes using best model checkpoint.</a:t>
+            </a:r>
+            <a:endParaRPr b="0" i="0" sz="1100" u="none" cap="none" strike="noStrike">
+              <a:solidFill>
+                <a:schemeClr val="dk1"/>
+              </a:solidFill>
+              <a:latin typeface="Calibri"/>
+              <a:ea typeface="Calibri"/>
+              <a:cs typeface="Calibri"/>
+              <a:sym typeface="Calibri"/>
+            </a:endParaRPr>
+          </a:p>
+        </p:txBody>
+      </p:sp>
+      <p:sp>
+        <p:nvSpPr>
+          <p:cNvPr id="110" name="Google Shape;110;g395f996db06_0_0"/>
+          <p:cNvSpPr/>
+          <p:nvPr/>
+        </p:nvSpPr>
+        <p:spPr>
+          <a:xfrm>
+            <a:off x="457200" y="4663440"/>
+            <a:ext cx="8229600" cy="365700"/>
+          </a:xfrm>
+          <a:prstGeom prst="rect">
+            <a:avLst/>
+          </a:prstGeom>
+          <a:noFill/>
+          <a:ln>
+            <a:noFill/>
+          </a:ln>
+        </p:spPr>
+        <p:txBody>
+          <a:bodyPr anchorCtr="0" anchor="ctr" bIns="45700" lIns="91425" spcFirstLastPara="1" rIns="91425" wrap="square" tIns="45700">
+            <a:noAutofit/>
+          </a:bodyPr>
+          <a:lstStyle/>
+          <a:p>
+            <a:pPr indent="0" lvl="0" marL="0" marR="0" rtl="0" algn="l">
+              <a:spcBef>
+                <a:spcPts val="0"/>
+              </a:spcBef>
+              <a:spcAft>
+                <a:spcPts val="0"/>
+              </a:spcAft>
+              <a:buClr>
+                <a:srgbClr val="64748B"/>
+              </a:buClr>
+              <a:buSzPts val="900"/>
+              <a:buFont typeface="Calibri"/>
+              <a:buNone/>
+            </a:pPr>
+            <a:r>
+              <a:rPr b="0" i="0" lang="en-US" sz="900" u="none" cap="none" strike="noStrike">
+                <a:solidFill>
+                  <a:srgbClr val="64748B"/>
+                </a:solidFill>
+                <a:latin typeface="Calibri"/>
+                <a:ea typeface="Calibri"/>
+                <a:cs typeface="Calibri"/>
+                <a:sym typeface="Calibri"/>
+              </a:rPr>
+              <a:t>DQN Evaluation Results</a:t>
+            </a:r>
+            <a:endParaRPr b="0" i="0" sz="900" u="none" cap="none" strike="noStrike">
+              <a:solidFill>
+                <a:schemeClr val="dk1"/>
+              </a:solidFill>
+              <a:latin typeface="Calibri"/>
+              <a:ea typeface="Calibri"/>
+              <a:cs typeface="Calibri"/>
+              <a:sym typeface="Calibri"/>
+            </a:endParaRPr>
+          </a:p>
+        </p:txBody>
+      </p:sp>
+      <p:sp>
+        <p:nvSpPr>
+          <p:cNvPr id="111" name="Google Shape;111;g395f996db06_0_0"/>
+          <p:cNvSpPr/>
+          <p:nvPr/>
+        </p:nvSpPr>
+        <p:spPr>
+          <a:xfrm>
+            <a:off x="6126492" y="1188720"/>
+            <a:ext cx="2560200" cy="1463100"/>
+          </a:xfrm>
+          <a:prstGeom prst="rect">
+            <a:avLst/>
+          </a:prstGeom>
+          <a:solidFill>
+            <a:srgbClr val="FFFFFF"/>
+          </a:solidFill>
+          <a:ln>
+            <a:noFill/>
+          </a:ln>
+          <a:effectLst>
+            <a:outerShdw blurRad="76200" rotWithShape="0" algn="bl" dir="8100000" dist="25400">
+              <a:srgbClr val="000000">
+                <a:alpha val="7840"/>
+              </a:srgbClr>
+            </a:outerShdw>
+          </a:effectLst>
+        </p:spPr>
+        <p:txBody>
+          <a:bodyPr anchorCtr="0" anchor="ctr" bIns="91425" lIns="91425" spcFirstLastPara="1" rIns="91425" wrap="square" tIns="91425">
+            <a:noAutofit/>
+          </a:bodyPr>
+          <a:lstStyle/>
+          <a:p>
+            <a:pPr indent="0" lvl="0" marL="0" rtl="0" algn="l">
+              <a:spcBef>
+                <a:spcPts val="0"/>
+              </a:spcBef>
+              <a:spcAft>
+                <a:spcPts val="0"/>
+              </a:spcAft>
+              <a:buNone/>
+            </a:pPr>
+            <a:r>
+              <a:t/>
+            </a:r>
+            <a:endParaRPr/>
+          </a:p>
+        </p:txBody>
+      </p:sp>
+      <p:sp>
+        <p:nvSpPr>
+          <p:cNvPr id="112" name="Google Shape;112;g395f996db06_0_0"/>
+          <p:cNvSpPr/>
+          <p:nvPr/>
+        </p:nvSpPr>
+        <p:spPr>
+          <a:xfrm>
+            <a:off x="6126492" y="1325880"/>
+            <a:ext cx="2560200" cy="822900"/>
+          </a:xfrm>
+          <a:prstGeom prst="rect">
+            <a:avLst/>
+          </a:prstGeom>
+          <a:noFill/>
+          <a:ln>
+            <a:noFill/>
+          </a:ln>
+        </p:spPr>
+        <p:txBody>
+          <a:bodyPr anchorCtr="0" anchor="ctr" bIns="0" lIns="0" spcFirstLastPara="1" rIns="0" wrap="square" tIns="0">
+            <a:noAutofit/>
+          </a:bodyPr>
+          <a:lstStyle/>
+          <a:p>
+            <a:pPr indent="0" lvl="0" marL="0" marR="0" rtl="0" algn="ctr">
+              <a:spcBef>
+                <a:spcPts val="0"/>
+              </a:spcBef>
+              <a:spcAft>
+                <a:spcPts val="0"/>
+              </a:spcAft>
+              <a:buClr>
+                <a:srgbClr val="0891B2"/>
+              </a:buClr>
+              <a:buSzPts val="4400"/>
+              <a:buFont typeface="Trebuchet MS"/>
+              <a:buNone/>
+            </a:pPr>
+            <a:r>
+              <a:rPr b="1" lang="en-US" sz="4400">
+                <a:solidFill>
+                  <a:srgbClr val="0891B2"/>
+                </a:solidFill>
+                <a:latin typeface="Trebuchet MS"/>
+                <a:ea typeface="Trebuchet MS"/>
+                <a:cs typeface="Trebuchet MS"/>
+                <a:sym typeface="Trebuchet MS"/>
+              </a:rPr>
+              <a:t>4.5</a:t>
+            </a:r>
+            <a:endParaRPr b="0" i="0" sz="4400" u="none" cap="none" strike="noStrike">
+              <a:solidFill>
+                <a:schemeClr val="dk1"/>
+              </a:solidFill>
+              <a:latin typeface="Calibri"/>
+              <a:ea typeface="Calibri"/>
+              <a:cs typeface="Calibri"/>
+              <a:sym typeface="Calibri"/>
+            </a:endParaRPr>
+          </a:p>
+        </p:txBody>
+      </p:sp>
+      <p:sp>
+        <p:nvSpPr>
+          <p:cNvPr id="113" name="Google Shape;113;g395f996db06_0_0"/>
+          <p:cNvSpPr/>
+          <p:nvPr/>
+        </p:nvSpPr>
+        <p:spPr>
+          <a:xfrm>
+            <a:off x="6126492" y="2148840"/>
+            <a:ext cx="2560200" cy="365700"/>
+          </a:xfrm>
+          <a:prstGeom prst="rect">
+            <a:avLst/>
+          </a:prstGeom>
+          <a:noFill/>
+          <a:ln>
+            <a:noFill/>
+          </a:ln>
+        </p:spPr>
+        <p:txBody>
+          <a:bodyPr anchorCtr="0" anchor="ctr" bIns="0" lIns="0" spcFirstLastPara="1" rIns="0" wrap="square" tIns="0">
+            <a:noAutofit/>
+          </a:bodyPr>
+          <a:lstStyle/>
+          <a:p>
+            <a:pPr indent="0" lvl="0" marL="0" marR="0" rtl="0" algn="ctr">
+              <a:spcBef>
+                <a:spcPts val="0"/>
+              </a:spcBef>
+              <a:spcAft>
+                <a:spcPts val="0"/>
+              </a:spcAft>
+              <a:buClr>
+                <a:srgbClr val="64748B"/>
+              </a:buClr>
+              <a:buSzPts val="1200"/>
+              <a:buFont typeface="Calibri"/>
+              <a:buNone/>
+            </a:pPr>
+            <a:r>
+              <a:rPr b="0" i="0" lang="en-US" sz="1200" u="none" cap="none" strike="noStrike">
+                <a:solidFill>
+                  <a:srgbClr val="64748B"/>
+                </a:solidFill>
+                <a:latin typeface="Calibri"/>
+                <a:ea typeface="Calibri"/>
+                <a:cs typeface="Calibri"/>
+                <a:sym typeface="Calibri"/>
+              </a:rPr>
+              <a:t>Avg </a:t>
+            </a:r>
+            <a:r>
+              <a:rPr lang="en-US" sz="1200">
+                <a:solidFill>
+                  <a:srgbClr val="64748B"/>
+                </a:solidFill>
+                <a:latin typeface="Calibri"/>
+                <a:ea typeface="Calibri"/>
+                <a:cs typeface="Calibri"/>
+                <a:sym typeface="Calibri"/>
+              </a:rPr>
+              <a:t>Round</a:t>
+            </a:r>
+            <a:endParaRPr b="0" i="0" sz="1200" u="none" cap="none" strike="noStrike">
+              <a:solidFill>
+                <a:schemeClr val="dk1"/>
+              </a:solidFill>
+              <a:latin typeface="Calibri"/>
+              <a:ea typeface="Calibri"/>
+              <a:cs typeface="Calibri"/>
+              <a:sym typeface="Calibri"/>
+            </a:endParaRPr>
+          </a:p>
+        </p:txBody>
+      </p:sp>
+    </p:spTree>
+  </p:cSld>
+  <p:clrMapOvr>
+    <a:masterClrMapping/>
+  </p:clrMapOvr>
+</p:sld>
+</file>
+
+<file path=ppt/slides/slide11.xml><?xml version="1.0" encoding="utf-8"?>
+<p:sld xmlns:a="http://schemas.openxmlformats.org/drawingml/2006/main" xmlns:r="http://schemas.openxmlformats.org/officeDocument/2006/relationships" xmlns:mc="http://schemas.openxmlformats.org/markup-compatibility/2006" xmlns:mv="urn:schemas-microsoft-com:mac:vml" xmlns:p="http://schemas.openxmlformats.org/presentationml/2006/main" xmlns:c="http://schemas.openxmlformats.org/drawingml/2006/chart" xmlns:dgm="http://schemas.openxmlformats.org/drawingml/2006/diagram" xmlns:o="urn:schemas-microsoft-com:office:office" xmlns:v="urn:schemas-microsoft-com:vml" xmlns:pvml="urn:schemas-microsoft-com:office:powerpoint" xmlns:com="http://schemas.openxmlformats.org/drawingml/2006/compatibility" xmlns:p14="http://schemas.microsoft.com/office/powerpoint/2010/main" xmlns:p15="http://schemas.microsoft.com/office/powerpoint/2012/main" xmlns:ahyp="http://schemas.microsoft.com/office/drawing/2018/hyperlinkcolor">
+  <p:cSld>
+    <p:bg>
+      <p:bgPr>
+        <a:solidFill>
+          <a:srgbClr val="FFFFFF"/>
+        </a:solidFill>
+      </p:bgPr>
+    </p:bg>
+    <p:spTree>
+      <p:nvGrpSpPr>
+        <p:cNvPr id="118" name="Shape 118"/>
+        <p:cNvGrpSpPr/>
+        <p:nvPr/>
+      </p:nvGrpSpPr>
+      <p:grpSpPr>
+        <a:xfrm>
+          <a:off x="0" y="0"/>
+          <a:ext cx="0" cy="0"/>
+          <a:chOff x="0" y="0"/>
+          <a:chExt cx="0" cy="0"/>
+        </a:xfrm>
+      </p:grpSpPr>
+      <p:sp>
+        <p:nvSpPr>
+          <p:cNvPr id="119" name="Google Shape;119;p11"/>
           <p:cNvSpPr/>
           <p:nvPr/>
         </p:nvSpPr>
@@ -5361,7 +6316,7 @@
       </p:sp>
       <p:pic>
         <p:nvPicPr>
-          <p:cNvPr descr="preencoded.png" id="112" name="Google Shape;112;p11"/>
+          <p:cNvPr descr="preencoded.png" id="120" name="Google Shape;120;p11"/>
           <p:cNvPicPr preferRelativeResize="0"/>
           <p:nvPr/>
         </p:nvPicPr>
@@ -5394,7 +6349,7 @@
 </p:sld>
 </file>
 
-<file path=ppt/slides/slide11.xml><?xml version="1.0" encoding="utf-8"?>
+<file path=ppt/slides/slide12.xml><?xml version="1.0" encoding="utf-8"?>
 <p:sld xmlns:a="http://schemas.openxmlformats.org/drawingml/2006/main" xmlns:r="http://schemas.openxmlformats.org/officeDocument/2006/relationships" xmlns:mc="http://schemas.openxmlformats.org/markup-compatibility/2006" xmlns:mv="urn:schemas-microsoft-com:mac:vml" xmlns:p="http://schemas.openxmlformats.org/presentationml/2006/main" xmlns:c="http://schemas.openxmlformats.org/drawingml/2006/chart" xmlns:dgm="http://schemas.openxmlformats.org/drawingml/2006/diagram" xmlns:o="urn:schemas-microsoft-com:office:office" xmlns:v="urn:schemas-microsoft-com:vml" xmlns:pvml="urn:schemas-microsoft-com:office:powerpoint" xmlns:com="http://schemas.openxmlformats.org/drawingml/2006/compatibility" xmlns:p14="http://schemas.microsoft.com/office/powerpoint/2010/main" xmlns:p15="http://schemas.microsoft.com/office/powerpoint/2012/main" xmlns:ahyp="http://schemas.microsoft.com/office/drawing/2018/hyperlinkcolor">
   <p:cSld>
     <p:bg>
@@ -5406,7 +6361,7 @@
     </p:bg>
     <p:spTree>
       <p:nvGrpSpPr>
-        <p:cNvPr id="117" name="Shape 117"/>
+        <p:cNvPr id="125" name="Shape 125"/>
         <p:cNvGrpSpPr/>
         <p:nvPr/>
       </p:nvGrpSpPr>
@@ -5420,7 +6375,7 @@
       </p:grpSpPr>
       <p:sp>
         <p:nvSpPr>
-          <p:cNvPr id="118" name="Google Shape;118;p12"/>
+          <p:cNvPr id="126" name="Google Shape;126;p12"/>
           <p:cNvSpPr/>
           <p:nvPr/>
         </p:nvSpPr>
@@ -5483,7 +6438,7 @@
       </p:sp>
       <p:sp>
         <p:nvSpPr>
-          <p:cNvPr id="119" name="Google Shape;119;p12"/>
+          <p:cNvPr id="127" name="Google Shape;127;p12"/>
           <p:cNvSpPr/>
           <p:nvPr/>
         </p:nvSpPr>
@@ -5546,7 +6501,7 @@
       </p:sp>
       <p:pic>
         <p:nvPicPr>
-          <p:cNvPr descr="preencoded.png" id="120" name="Google Shape;120;p12"/>
+          <p:cNvPr descr="preencoded.png" id="128" name="Google Shape;128;p12"/>
           <p:cNvPicPr preferRelativeResize="0"/>
           <p:nvPr/>
         </p:nvPicPr>
@@ -5573,7 +6528,7 @@
       </p:pic>
       <p:sp>
         <p:nvSpPr>
-          <p:cNvPr id="121" name="Google Shape;121;p12"/>
+          <p:cNvPr id="129" name="Google Shape;129;p12"/>
           <p:cNvSpPr/>
           <p:nvPr/>
         </p:nvSpPr>
@@ -5596,7 +6551,7 @@
           </a:bodyPr>
           <a:lstStyle/>
           <a:p>
-            <a:pPr indent="0" lvl="0" marL="0" marR="0" rtl="0" algn="ctr">
+            <a:pPr indent="0" lvl="0" marL="0" rtl="0" algn="ctr">
               <a:spcBef>
                 <a:spcPts val="0"/>
               </a:spcBef>
@@ -5611,7 +6566,7 @@
               <a:buNone/>
             </a:pPr>
             <a:r>
-              <a:rPr b="1" i="0" lang="en-US" sz="1100" u="none" cap="none" strike="noStrike">
+              <a:rPr b="1" lang="en-US" sz="1100">
                 <a:solidFill>
                   <a:srgbClr val="64748B"/>
                 </a:solidFill>
@@ -5620,7 +6575,7 @@
                 <a:cs typeface="Calibri"/>
                 <a:sym typeface="Calibri"/>
               </a:rPr>
-              <a:t>Excluding Exit Actions (Topic ≠ D)</a:t>
+              <a:t>Excluding Topic D</a:t>
             </a:r>
             <a:endParaRPr b="0" i="0" sz="1100" u="none" cap="none" strike="noStrike">
               <a:solidFill>
@@ -5636,7 +6591,7 @@
       </p:sp>
       <p:pic>
         <p:nvPicPr>
-          <p:cNvPr descr="preencoded.png" id="122" name="Google Shape;122;p12"/>
+          <p:cNvPr descr="preencoded.png" id="130" name="Google Shape;130;p12"/>
           <p:cNvPicPr preferRelativeResize="0"/>
           <p:nvPr/>
         </p:nvPicPr>
@@ -5669,7 +6624,7 @@
 </p:sld>
 </file>
 
-<file path=ppt/slides/slide12.xml><?xml version="1.0" encoding="utf-8"?>
+<file path=ppt/slides/slide13.xml><?xml version="1.0" encoding="utf-8"?>
 <p:sld xmlns:a="http://schemas.openxmlformats.org/drawingml/2006/main" xmlns:r="http://schemas.openxmlformats.org/officeDocument/2006/relationships" xmlns:mc="http://schemas.openxmlformats.org/markup-compatibility/2006" xmlns:mv="urn:schemas-microsoft-com:mac:vml" xmlns:p="http://schemas.openxmlformats.org/presentationml/2006/main" xmlns:c="http://schemas.openxmlformats.org/drawingml/2006/chart" xmlns:dgm="http://schemas.openxmlformats.org/drawingml/2006/diagram" xmlns:o="urn:schemas-microsoft-com:office:office" xmlns:v="urn:schemas-microsoft-com:vml" xmlns:pvml="urn:schemas-microsoft-com:office:powerpoint" xmlns:com="http://schemas.openxmlformats.org/drawingml/2006/compatibility" xmlns:p14="http://schemas.microsoft.com/office/powerpoint/2010/main" xmlns:p15="http://schemas.microsoft.com/office/powerpoint/2012/main" xmlns:ahyp="http://schemas.microsoft.com/office/drawing/2018/hyperlinkcolor">
   <p:cSld>
     <p:bg>
@@ -5681,7 +6636,7 @@
     </p:bg>
     <p:spTree>
       <p:nvGrpSpPr>
-        <p:cNvPr id="127" name="Shape 127"/>
+        <p:cNvPr id="135" name="Shape 135"/>
         <p:cNvGrpSpPr/>
         <p:nvPr/>
       </p:nvGrpSpPr>
@@ -5695,7 +6650,462 @@
       </p:grpSpPr>
       <p:sp>
         <p:nvSpPr>
-          <p:cNvPr id="128" name="Google Shape;128;p13"/>
+          <p:cNvPr id="136" name="Google Shape;136;g395f996db06_0_49"/>
+          <p:cNvSpPr/>
+          <p:nvPr/>
+        </p:nvSpPr>
+        <p:spPr>
+          <a:xfrm>
+            <a:off x="457200" y="274320"/>
+            <a:ext cx="8229600" cy="731400"/>
+          </a:xfrm>
+          <a:prstGeom prst="rect">
+            <a:avLst/>
+          </a:prstGeom>
+          <a:noFill/>
+          <a:ln>
+            <a:noFill/>
+          </a:ln>
+        </p:spPr>
+        <p:txBody>
+          <a:bodyPr anchorCtr="0" anchor="ctr" bIns="0" lIns="0" spcFirstLastPara="1" rIns="0" wrap="square" tIns="0">
+            <a:noAutofit/>
+          </a:bodyPr>
+          <a:lstStyle/>
+          <a:p>
+            <a:pPr indent="0" lvl="0" marL="0" marR="0" rtl="0" algn="l">
+              <a:spcBef>
+                <a:spcPts val="0"/>
+              </a:spcBef>
+              <a:spcAft>
+                <a:spcPts val="0"/>
+              </a:spcAft>
+              <a:buClr>
+                <a:srgbClr val="FFFFFF"/>
+              </a:buClr>
+              <a:buSzPts val="2800"/>
+              <a:buFont typeface="Trebuchet MS"/>
+              <a:buNone/>
+            </a:pPr>
+            <a:r>
+              <a:rPr b="1" i="0" lang="en-US" sz="2800" u="none" cap="none" strike="noStrike">
+                <a:solidFill>
+                  <a:srgbClr val="FFFFFF"/>
+                </a:solidFill>
+                <a:latin typeface="Trebuchet MS"/>
+                <a:ea typeface="Trebuchet MS"/>
+                <a:cs typeface="Trebuchet MS"/>
+                <a:sym typeface="Trebuchet MS"/>
+              </a:rPr>
+              <a:t>Key Takeaways</a:t>
+            </a:r>
+            <a:endParaRPr b="0" i="0" sz="2800" u="none" cap="none" strike="noStrike">
+              <a:solidFill>
+                <a:schemeClr val="dk1"/>
+              </a:solidFill>
+              <a:latin typeface="Calibri"/>
+              <a:ea typeface="Calibri"/>
+              <a:cs typeface="Calibri"/>
+              <a:sym typeface="Calibri"/>
+            </a:endParaRPr>
+          </a:p>
+        </p:txBody>
+      </p:sp>
+      <p:sp>
+        <p:nvSpPr>
+          <p:cNvPr id="137" name="Google Shape;137;g395f996db06_0_49"/>
+          <p:cNvSpPr/>
+          <p:nvPr/>
+        </p:nvSpPr>
+        <p:spPr>
+          <a:xfrm>
+            <a:off x="457200" y="1097280"/>
+            <a:ext cx="8229600" cy="3657600"/>
+          </a:xfrm>
+          <a:prstGeom prst="rect">
+            <a:avLst/>
+          </a:prstGeom>
+          <a:noFill/>
+          <a:ln>
+            <a:noFill/>
+          </a:ln>
+        </p:spPr>
+        <p:txBody>
+          <a:bodyPr anchorCtr="0" anchor="t" bIns="45700" lIns="91425" spcFirstLastPara="1" rIns="91425" wrap="square" tIns="45700">
+            <a:noAutofit/>
+          </a:bodyPr>
+          <a:lstStyle/>
+          <a:p>
+            <a:pPr indent="0" lvl="0" marL="0" marR="0" rtl="0" algn="l">
+              <a:spcBef>
+                <a:spcPts val="0"/>
+              </a:spcBef>
+              <a:spcAft>
+                <a:spcPts val="0"/>
+              </a:spcAft>
+              <a:buClr>
+                <a:srgbClr val="64748B"/>
+              </a:buClr>
+              <a:buSzPts val="1300"/>
+              <a:buFont typeface="Calibri"/>
+              <a:buNone/>
+            </a:pPr>
+            <a:r>
+              <a:rPr b="1" lang="en-US" sz="1600">
+                <a:solidFill>
+                  <a:schemeClr val="lt1"/>
+                </a:solidFill>
+                <a:latin typeface="Trebuchet MS"/>
+                <a:ea typeface="Trebuchet MS"/>
+                <a:cs typeface="Trebuchet MS"/>
+                <a:sym typeface="Trebuchet MS"/>
+              </a:rPr>
+              <a:t>Objection Handling Strategy</a:t>
+            </a:r>
+            <a:endParaRPr b="1" sz="1600">
+              <a:solidFill>
+                <a:schemeClr val="lt1"/>
+              </a:solidFill>
+              <a:latin typeface="Trebuchet MS"/>
+              <a:ea typeface="Trebuchet MS"/>
+              <a:cs typeface="Trebuchet MS"/>
+              <a:sym typeface="Trebuchet MS"/>
+            </a:endParaRPr>
+          </a:p>
+          <a:p>
+            <a:pPr indent="0" lvl="0" marL="0" marR="0" rtl="0" algn="l">
+              <a:spcBef>
+                <a:spcPts val="0"/>
+              </a:spcBef>
+              <a:spcAft>
+                <a:spcPts val="0"/>
+              </a:spcAft>
+              <a:buClr>
+                <a:srgbClr val="64748B"/>
+              </a:buClr>
+              <a:buSzPts val="1300"/>
+              <a:buFont typeface="Calibri"/>
+              <a:buNone/>
+            </a:pPr>
+            <a:r>
+              <a:rPr lang="en-US" sz="1300">
+                <a:solidFill>
+                  <a:schemeClr val="lt1"/>
+                </a:solidFill>
+                <a:latin typeface="Calibri"/>
+                <a:ea typeface="Calibri"/>
+                <a:cs typeface="Calibri"/>
+                <a:sym typeface="Calibri"/>
+              </a:rPr>
+              <a:t>If objection is A/B/C: still prioritize incentives. (Always use incentive at round 1.) But has a higher percentage of persuade than when exit threshold = 5.</a:t>
+            </a:r>
+            <a:endParaRPr sz="1300">
+              <a:solidFill>
+                <a:schemeClr val="lt1"/>
+              </a:solidFill>
+              <a:latin typeface="Calibri"/>
+              <a:ea typeface="Calibri"/>
+              <a:cs typeface="Calibri"/>
+              <a:sym typeface="Calibri"/>
+            </a:endParaRPr>
+          </a:p>
+          <a:p>
+            <a:pPr indent="0" lvl="0" marL="0" marR="0" rtl="0" algn="l">
+              <a:spcBef>
+                <a:spcPts val="0"/>
+              </a:spcBef>
+              <a:spcAft>
+                <a:spcPts val="0"/>
+              </a:spcAft>
+              <a:buClr>
+                <a:srgbClr val="64748B"/>
+              </a:buClr>
+              <a:buSzPts val="1300"/>
+              <a:buFont typeface="Calibri"/>
+              <a:buNone/>
+            </a:pPr>
+            <a:r>
+              <a:rPr lang="en-US" sz="1300">
+                <a:solidFill>
+                  <a:schemeClr val="lt1"/>
+                </a:solidFill>
+                <a:latin typeface="Calibri"/>
+                <a:ea typeface="Calibri"/>
+                <a:cs typeface="Calibri"/>
+                <a:sym typeface="Calibri"/>
+              </a:rPr>
+              <a:t>If objection is D and round &lt; 5, persuade. If round &gt;= 5: enforce close.</a:t>
+            </a:r>
+            <a:endParaRPr sz="1300">
+              <a:solidFill>
+                <a:schemeClr val="lt1"/>
+              </a:solidFill>
+              <a:latin typeface="Calibri"/>
+              <a:ea typeface="Calibri"/>
+              <a:cs typeface="Calibri"/>
+              <a:sym typeface="Calibri"/>
+            </a:endParaRPr>
+          </a:p>
+          <a:p>
+            <a:pPr indent="0" lvl="0" marL="0" marR="0" rtl="0" algn="l">
+              <a:spcBef>
+                <a:spcPts val="0"/>
+              </a:spcBef>
+              <a:spcAft>
+                <a:spcPts val="0"/>
+              </a:spcAft>
+              <a:buClr>
+                <a:srgbClr val="64748B"/>
+              </a:buClr>
+              <a:buSzPts val="1300"/>
+              <a:buFont typeface="Calibri"/>
+              <a:buNone/>
+            </a:pPr>
+            <a:r>
+              <a:t/>
+            </a:r>
+            <a:endParaRPr sz="1300">
+              <a:solidFill>
+                <a:schemeClr val="lt1"/>
+              </a:solidFill>
+              <a:latin typeface="Calibri"/>
+              <a:ea typeface="Calibri"/>
+              <a:cs typeface="Calibri"/>
+              <a:sym typeface="Calibri"/>
+            </a:endParaRPr>
+          </a:p>
+          <a:p>
+            <a:pPr indent="0" lvl="0" marL="0" rtl="0" algn="l">
+              <a:spcBef>
+                <a:spcPts val="0"/>
+              </a:spcBef>
+              <a:spcAft>
+                <a:spcPts val="0"/>
+              </a:spcAft>
+              <a:buClr>
+                <a:srgbClr val="64748B"/>
+              </a:buClr>
+              <a:buSzPts val="1300"/>
+              <a:buFont typeface="Calibri"/>
+              <a:buNone/>
+            </a:pPr>
+            <a:r>
+              <a:rPr b="1" lang="en-US" sz="1600">
+                <a:solidFill>
+                  <a:schemeClr val="lt1"/>
+                </a:solidFill>
+                <a:latin typeface="Trebuchet MS"/>
+                <a:ea typeface="Trebuchet MS"/>
+                <a:cs typeface="Trebuchet MS"/>
+                <a:sym typeface="Trebuchet MS"/>
+              </a:rPr>
+              <a:t>Early Closing</a:t>
+            </a:r>
+            <a:endParaRPr b="1" sz="1600">
+              <a:solidFill>
+                <a:schemeClr val="lt1"/>
+              </a:solidFill>
+              <a:latin typeface="Trebuchet MS"/>
+              <a:ea typeface="Trebuchet MS"/>
+              <a:cs typeface="Trebuchet MS"/>
+              <a:sym typeface="Trebuchet MS"/>
+            </a:endParaRPr>
+          </a:p>
+          <a:p>
+            <a:pPr indent="0" lvl="0" marL="0" rtl="0" algn="l">
+              <a:spcBef>
+                <a:spcPts val="0"/>
+              </a:spcBef>
+              <a:spcAft>
+                <a:spcPts val="0"/>
+              </a:spcAft>
+              <a:buClr>
+                <a:srgbClr val="64748B"/>
+              </a:buClr>
+              <a:buSzPts val="1300"/>
+              <a:buFont typeface="Calibri"/>
+              <a:buNone/>
+            </a:pPr>
+            <a:r>
+              <a:rPr lang="en-US" sz="1300">
+                <a:solidFill>
+                  <a:schemeClr val="lt1"/>
+                </a:solidFill>
+                <a:latin typeface="Calibri"/>
+                <a:ea typeface="Calibri"/>
+                <a:cs typeface="Calibri"/>
+                <a:sym typeface="Calibri"/>
+              </a:rPr>
+              <a:t>If objection is A/B/C: closing starting at round 7 (moderately), enforce closing at round 8 and after.</a:t>
+            </a:r>
+            <a:endParaRPr sz="1300">
+              <a:solidFill>
+                <a:schemeClr val="lt1"/>
+              </a:solidFill>
+              <a:latin typeface="Calibri"/>
+              <a:ea typeface="Calibri"/>
+              <a:cs typeface="Calibri"/>
+              <a:sym typeface="Calibri"/>
+            </a:endParaRPr>
+          </a:p>
+          <a:p>
+            <a:pPr indent="0" lvl="0" marL="0" rtl="0" algn="l">
+              <a:spcBef>
+                <a:spcPts val="0"/>
+              </a:spcBef>
+              <a:spcAft>
+                <a:spcPts val="0"/>
+              </a:spcAft>
+              <a:buClr>
+                <a:srgbClr val="64748B"/>
+              </a:buClr>
+              <a:buSzPts val="1300"/>
+              <a:buFont typeface="Calibri"/>
+              <a:buNone/>
+            </a:pPr>
+            <a:r>
+              <a:rPr lang="en-US" sz="1300">
+                <a:solidFill>
+                  <a:schemeClr val="lt1"/>
+                </a:solidFill>
+                <a:latin typeface="Calibri"/>
+                <a:ea typeface="Calibri"/>
+                <a:cs typeface="Calibri"/>
+                <a:sym typeface="Calibri"/>
+              </a:rPr>
+              <a:t>If objection is D, moderate closing at round 4, enforce at round 6 and after.</a:t>
+            </a:r>
+            <a:endParaRPr sz="1300">
+              <a:solidFill>
+                <a:schemeClr val="lt1"/>
+              </a:solidFill>
+              <a:latin typeface="Calibri"/>
+              <a:ea typeface="Calibri"/>
+              <a:cs typeface="Calibri"/>
+              <a:sym typeface="Calibri"/>
+            </a:endParaRPr>
+          </a:p>
+          <a:p>
+            <a:pPr indent="0" lvl="0" marL="0" rtl="0" algn="l">
+              <a:spcBef>
+                <a:spcPts val="0"/>
+              </a:spcBef>
+              <a:spcAft>
+                <a:spcPts val="0"/>
+              </a:spcAft>
+              <a:buClr>
+                <a:srgbClr val="64748B"/>
+              </a:buClr>
+              <a:buSzPts val="1300"/>
+              <a:buFont typeface="Calibri"/>
+              <a:buNone/>
+            </a:pPr>
+            <a:r>
+              <a:t/>
+            </a:r>
+            <a:endParaRPr b="1" sz="1600">
+              <a:solidFill>
+                <a:schemeClr val="lt1"/>
+              </a:solidFill>
+              <a:latin typeface="Trebuchet MS"/>
+              <a:ea typeface="Trebuchet MS"/>
+              <a:cs typeface="Trebuchet MS"/>
+              <a:sym typeface="Trebuchet MS"/>
+            </a:endParaRPr>
+          </a:p>
+          <a:p>
+            <a:pPr indent="0" lvl="0" marL="0" rtl="0" algn="l">
+              <a:spcBef>
+                <a:spcPts val="0"/>
+              </a:spcBef>
+              <a:spcAft>
+                <a:spcPts val="0"/>
+              </a:spcAft>
+              <a:buClr>
+                <a:srgbClr val="64748B"/>
+              </a:buClr>
+              <a:buSzPts val="1300"/>
+              <a:buFont typeface="Calibri"/>
+              <a:buNone/>
+            </a:pPr>
+            <a:r>
+              <a:t/>
+            </a:r>
+            <a:endParaRPr b="1" sz="1600">
+              <a:solidFill>
+                <a:schemeClr val="lt1"/>
+              </a:solidFill>
+              <a:latin typeface="Trebuchet MS"/>
+              <a:ea typeface="Trebuchet MS"/>
+              <a:cs typeface="Trebuchet MS"/>
+              <a:sym typeface="Trebuchet MS"/>
+            </a:endParaRPr>
+          </a:p>
+          <a:p>
+            <a:pPr indent="0" lvl="0" marL="0" marR="0" rtl="0" algn="l">
+              <a:spcBef>
+                <a:spcPts val="0"/>
+              </a:spcBef>
+              <a:spcAft>
+                <a:spcPts val="0"/>
+              </a:spcAft>
+              <a:buClr>
+                <a:srgbClr val="64748B"/>
+              </a:buClr>
+              <a:buSzPts val="1300"/>
+              <a:buFont typeface="Calibri"/>
+              <a:buNone/>
+            </a:pPr>
+            <a:r>
+              <a:t/>
+            </a:r>
+            <a:endParaRPr sz="1600">
+              <a:solidFill>
+                <a:schemeClr val="lt1"/>
+              </a:solidFill>
+              <a:latin typeface="Calibri"/>
+              <a:ea typeface="Calibri"/>
+              <a:cs typeface="Calibri"/>
+              <a:sym typeface="Calibri"/>
+            </a:endParaRPr>
+          </a:p>
+        </p:txBody>
+      </p:sp>
+    </p:spTree>
+  </p:cSld>
+  <p:clrMapOvr>
+    <a:masterClrMapping/>
+  </p:clrMapOvr>
+</p:sld>
+</file>
+
+<file path=ppt/slides/slide14.xml><?xml version="1.0" encoding="utf-8"?>
+<p:sld xmlns:a="http://schemas.openxmlformats.org/drawingml/2006/main" xmlns:r="http://schemas.openxmlformats.org/officeDocument/2006/relationships" xmlns:mc="http://schemas.openxmlformats.org/markup-compatibility/2006" xmlns:mv="urn:schemas-microsoft-com:mac:vml" xmlns:p="http://schemas.openxmlformats.org/presentationml/2006/main" xmlns:c="http://schemas.openxmlformats.org/drawingml/2006/chart" xmlns:dgm="http://schemas.openxmlformats.org/drawingml/2006/diagram" xmlns:o="urn:schemas-microsoft-com:office:office" xmlns:v="urn:schemas-microsoft-com:vml" xmlns:pvml="urn:schemas-microsoft-com:office:powerpoint" xmlns:com="http://schemas.openxmlformats.org/drawingml/2006/compatibility" xmlns:p14="http://schemas.microsoft.com/office/powerpoint/2010/main" xmlns:p15="http://schemas.microsoft.com/office/powerpoint/2012/main" xmlns:ahyp="http://schemas.microsoft.com/office/drawing/2018/hyperlinkcolor">
+  <p:cSld>
+    <p:bg>
+      <p:bgPr>
+        <a:solidFill>
+          <a:srgbClr val="1E293B"/>
+        </a:solidFill>
+      </p:bgPr>
+    </p:bg>
+    <p:spTree>
+      <p:nvGrpSpPr>
+        <p:cNvPr id="142" name="Shape 142"/>
+        <p:cNvGrpSpPr/>
+        <p:nvPr/>
+      </p:nvGrpSpPr>
+      <p:grpSpPr>
+        <a:xfrm>
+          <a:off x="0" y="0"/>
+          <a:ext cx="0" cy="0"/>
+          <a:chOff x="0" y="0"/>
+          <a:chExt cx="0" cy="0"/>
+        </a:xfrm>
+      </p:grpSpPr>
+      <p:sp>
+        <p:nvSpPr>
+          <p:cNvPr id="143" name="Google Shape;143;p13"/>
           <p:cNvSpPr/>
           <p:nvPr/>
         </p:nvSpPr>
@@ -5738,7 +7148,7 @@
       </p:sp>
       <p:sp>
         <p:nvSpPr>
-          <p:cNvPr id="129" name="Google Shape;129;p13"/>
+          <p:cNvPr id="144" name="Google Shape;144;p13"/>
           <p:cNvSpPr/>
           <p:nvPr/>
         </p:nvSpPr>
@@ -5801,7 +7211,7 @@
       </p:sp>
       <p:sp>
         <p:nvSpPr>
-          <p:cNvPr id="130" name="Google Shape;130;p13"/>
+          <p:cNvPr id="145" name="Google Shape;145;p13"/>
           <p:cNvSpPr/>
           <p:nvPr/>
         </p:nvSpPr>
@@ -5841,7 +7251,7 @@
             <a:r>
               <a:rPr b="0" i="0" lang="en-US" sz="1600" u="none" cap="none" strike="noStrike">
                 <a:solidFill>
-                  <a:srgbClr val="64748B"/>
+                  <a:schemeClr val="lt1"/>
                 </a:solidFill>
                 <a:latin typeface="Calibri"/>
                 <a:ea typeface="Calibri"/>
@@ -5850,9 +7260,21 @@
               </a:rPr>
               <a:t>A2C models</a:t>
             </a:r>
+            <a:r>
+              <a:rPr lang="en-US" sz="1600">
+                <a:solidFill>
+                  <a:schemeClr val="lt1"/>
+                </a:solidFill>
+                <a:latin typeface="Calibri"/>
+                <a:ea typeface="Calibri"/>
+                <a:cs typeface="Calibri"/>
+                <a:sym typeface="Calibri"/>
+              </a:rPr>
+              <a:t> with 2-layer MLP policy-net and value-net (both [128,64]).</a:t>
+            </a:r>
             <a:endParaRPr b="0" i="0" sz="1600" u="none" cap="none" strike="noStrike">
               <a:solidFill>
-                <a:schemeClr val="dk1"/>
+                <a:schemeClr val="lt1"/>
               </a:solidFill>
               <a:latin typeface="Calibri"/>
               <a:ea typeface="Calibri"/>
@@ -5870,7 +7292,7 @@
 </p:sld>
 </file>
 
-<file path=ppt/slides/slide13.xml><?xml version="1.0" encoding="utf-8"?>
+<file path=ppt/slides/slide15.xml><?xml version="1.0" encoding="utf-8"?>
 <p:sld xmlns:a="http://schemas.openxmlformats.org/drawingml/2006/main" xmlns:r="http://schemas.openxmlformats.org/officeDocument/2006/relationships" xmlns:mc="http://schemas.openxmlformats.org/markup-compatibility/2006" xmlns:mv="urn:schemas-microsoft-com:mac:vml" xmlns:p="http://schemas.openxmlformats.org/presentationml/2006/main" xmlns:c="http://schemas.openxmlformats.org/drawingml/2006/chart" xmlns:dgm="http://schemas.openxmlformats.org/drawingml/2006/diagram" xmlns:o="urn:schemas-microsoft-com:office:office" xmlns:v="urn:schemas-microsoft-com:vml" xmlns:pvml="urn:schemas-microsoft-com:office:powerpoint" xmlns:com="http://schemas.openxmlformats.org/drawingml/2006/compatibility" xmlns:p14="http://schemas.microsoft.com/office/powerpoint/2010/main" xmlns:p15="http://schemas.microsoft.com/office/powerpoint/2012/main" xmlns:ahyp="http://schemas.microsoft.com/office/drawing/2018/hyperlinkcolor">
   <p:cSld>
     <p:bg>
@@ -5882,7 +7304,7 @@
     </p:bg>
     <p:spTree>
       <p:nvGrpSpPr>
-        <p:cNvPr id="135" name="Shape 135"/>
+        <p:cNvPr id="150" name="Shape 150"/>
         <p:cNvGrpSpPr/>
         <p:nvPr/>
       </p:nvGrpSpPr>
@@ -5896,7 +7318,7 @@
       </p:grpSpPr>
       <p:sp>
         <p:nvSpPr>
-          <p:cNvPr id="136" name="Google Shape;136;p14"/>
+          <p:cNvPr id="151" name="Google Shape;151;p14"/>
           <p:cNvSpPr/>
           <p:nvPr/>
         </p:nvSpPr>
@@ -5959,7 +7381,7 @@
       </p:sp>
       <p:sp>
         <p:nvSpPr>
-          <p:cNvPr id="137" name="Google Shape;137;p14"/>
+          <p:cNvPr id="152" name="Google Shape;152;p14"/>
           <p:cNvSpPr/>
           <p:nvPr/>
         </p:nvSpPr>
@@ -6022,7 +7444,7 @@
       </p:sp>
       <p:sp>
         <p:nvSpPr>
-          <p:cNvPr id="138" name="Google Shape;138;p14"/>
+          <p:cNvPr id="153" name="Google Shape;153;p14"/>
           <p:cNvSpPr/>
           <p:nvPr/>
         </p:nvSpPr>
@@ -6196,7 +7618,7 @@
       </p:sp>
       <p:graphicFrame>
         <p:nvGraphicFramePr>
-          <p:cNvPr id="139" name="Google Shape;139;p14"/>
+          <p:cNvPr id="154" name="Google Shape;154;p14"/>
           <p:cNvGraphicFramePr/>
           <p:nvPr/>
         </p:nvGraphicFramePr>
@@ -6209,7 +7631,7 @@
             <a:tbl>
               <a:tblPr>
                 <a:noFill/>
-                <a:tableStyleId>{D5F6018F-751F-4F2E-BD67-FB7EB4D050E7}</a:tableStyleId>
+                <a:tableStyleId>{1FBCE98C-879A-4A73-B205-419AE505E898}</a:tableStyleId>
               </a:tblPr>
               <a:tblGrid>
                 <a:gridCol w="2263150"/>
@@ -7673,7 +9095,7 @@
       </p:graphicFrame>
       <p:sp>
         <p:nvSpPr>
-          <p:cNvPr id="140" name="Google Shape;140;p14"/>
+          <p:cNvPr id="155" name="Google Shape;155;p14"/>
           <p:cNvSpPr/>
           <p:nvPr/>
         </p:nvSpPr>
@@ -7742,7 +9164,7 @@
 </p:sld>
 </file>
 
-<file path=ppt/slides/slide14.xml><?xml version="1.0" encoding="utf-8"?>
+<file path=ppt/slides/slide16.xml><?xml version="1.0" encoding="utf-8"?>
 <p:sld xmlns:a="http://schemas.openxmlformats.org/drawingml/2006/main" xmlns:r="http://schemas.openxmlformats.org/officeDocument/2006/relationships" xmlns:mc="http://schemas.openxmlformats.org/markup-compatibility/2006" xmlns:mv="urn:schemas-microsoft-com:mac:vml" xmlns:p="http://schemas.openxmlformats.org/presentationml/2006/main" xmlns:c="http://schemas.openxmlformats.org/drawingml/2006/chart" xmlns:dgm="http://schemas.openxmlformats.org/drawingml/2006/diagram" xmlns:o="urn:schemas-microsoft-com:office:office" xmlns:v="urn:schemas-microsoft-com:vml" xmlns:pvml="urn:schemas-microsoft-com:office:powerpoint" xmlns:com="http://schemas.openxmlformats.org/drawingml/2006/compatibility" xmlns:p14="http://schemas.microsoft.com/office/powerpoint/2010/main" xmlns:p15="http://schemas.microsoft.com/office/powerpoint/2012/main" xmlns:ahyp="http://schemas.microsoft.com/office/drawing/2018/hyperlinkcolor">
   <p:cSld>
     <p:bg>
@@ -7754,7 +9176,7 @@
     </p:bg>
     <p:spTree>
       <p:nvGrpSpPr>
-        <p:cNvPr id="145" name="Shape 145"/>
+        <p:cNvPr id="160" name="Shape 160"/>
         <p:cNvGrpSpPr/>
         <p:nvPr/>
       </p:nvGrpSpPr>
@@ -7768,7 +9190,7 @@
       </p:grpSpPr>
       <p:sp>
         <p:nvSpPr>
-          <p:cNvPr id="146" name="Google Shape;146;p15"/>
+          <p:cNvPr id="161" name="Google Shape;161;p15"/>
           <p:cNvSpPr/>
           <p:nvPr/>
         </p:nvSpPr>
@@ -7831,7 +9253,7 @@
       </p:sp>
       <p:sp>
         <p:nvSpPr>
-          <p:cNvPr id="147" name="Google Shape;147;p15"/>
+          <p:cNvPr id="162" name="Google Shape;162;p15"/>
           <p:cNvSpPr/>
           <p:nvPr/>
         </p:nvSpPr>
@@ -7881,7 +9303,7 @@
       </p:sp>
       <p:sp>
         <p:nvSpPr>
-          <p:cNvPr id="148" name="Google Shape;148;p15"/>
+          <p:cNvPr id="163" name="Google Shape;163;p15"/>
           <p:cNvSpPr/>
           <p:nvPr/>
         </p:nvSpPr>
@@ -7944,7 +9366,7 @@
       </p:sp>
       <p:sp>
         <p:nvSpPr>
-          <p:cNvPr id="149" name="Google Shape;149;p15"/>
+          <p:cNvPr id="164" name="Google Shape;164;p15"/>
           <p:cNvSpPr/>
           <p:nvPr/>
         </p:nvSpPr>
@@ -8007,7 +9429,7 @@
       </p:sp>
       <p:sp>
         <p:nvSpPr>
-          <p:cNvPr id="150" name="Google Shape;150;p15"/>
+          <p:cNvPr id="165" name="Google Shape;165;p15"/>
           <p:cNvSpPr/>
           <p:nvPr/>
         </p:nvSpPr>
@@ -8057,7 +9479,7 @@
       </p:sp>
       <p:sp>
         <p:nvSpPr>
-          <p:cNvPr id="151" name="Google Shape;151;p15"/>
+          <p:cNvPr id="166" name="Google Shape;166;p15"/>
           <p:cNvSpPr/>
           <p:nvPr/>
         </p:nvSpPr>
@@ -8120,7 +9542,7 @@
       </p:sp>
       <p:sp>
         <p:nvSpPr>
-          <p:cNvPr id="152" name="Google Shape;152;p15"/>
+          <p:cNvPr id="167" name="Google Shape;167;p15"/>
           <p:cNvSpPr/>
           <p:nvPr/>
         </p:nvSpPr>
@@ -8183,7 +9605,7 @@
       </p:sp>
       <p:sp>
         <p:nvSpPr>
-          <p:cNvPr id="153" name="Google Shape;153;p15"/>
+          <p:cNvPr id="168" name="Google Shape;168;p15"/>
           <p:cNvSpPr/>
           <p:nvPr/>
         </p:nvSpPr>
@@ -8246,7 +9668,7 @@
       </p:sp>
       <p:sp>
         <p:nvSpPr>
-          <p:cNvPr id="154" name="Google Shape;154;p15"/>
+          <p:cNvPr id="169" name="Google Shape;169;p15"/>
           <p:cNvSpPr/>
           <p:nvPr/>
         </p:nvSpPr>
@@ -8309,7 +9731,7 @@
       </p:sp>
       <p:sp>
         <p:nvSpPr>
-          <p:cNvPr id="155" name="Google Shape;155;p15"/>
+          <p:cNvPr id="170" name="Google Shape;170;p15"/>
           <p:cNvSpPr/>
           <p:nvPr/>
         </p:nvSpPr>
@@ -8359,7 +9781,7 @@
       </p:sp>
       <p:sp>
         <p:nvSpPr>
-          <p:cNvPr id="156" name="Google Shape;156;p15"/>
+          <p:cNvPr id="171" name="Google Shape;171;p15"/>
           <p:cNvSpPr/>
           <p:nvPr/>
         </p:nvSpPr>
@@ -8422,7 +9844,7 @@
       </p:sp>
       <p:sp>
         <p:nvSpPr>
-          <p:cNvPr id="157" name="Google Shape;157;p15"/>
+          <p:cNvPr id="172" name="Google Shape;172;p15"/>
           <p:cNvSpPr/>
           <p:nvPr/>
         </p:nvSpPr>
@@ -8503,7 +9925,7 @@
 </p:sld>
 </file>
 
-<file path=ppt/slides/slide15.xml><?xml version="1.0" encoding="utf-8"?>
+<file path=ppt/slides/slide17.xml><?xml version="1.0" encoding="utf-8"?>
 <p:sld xmlns:a="http://schemas.openxmlformats.org/drawingml/2006/main" xmlns:r="http://schemas.openxmlformats.org/officeDocument/2006/relationships" xmlns:mc="http://schemas.openxmlformats.org/markup-compatibility/2006" xmlns:mv="urn:schemas-microsoft-com:mac:vml" xmlns:p="http://schemas.openxmlformats.org/presentationml/2006/main" xmlns:c="http://schemas.openxmlformats.org/drawingml/2006/chart" xmlns:dgm="http://schemas.openxmlformats.org/drawingml/2006/diagram" xmlns:o="urn:schemas-microsoft-com:office:office" xmlns:v="urn:schemas-microsoft-com:vml" xmlns:pvml="urn:schemas-microsoft-com:office:powerpoint" xmlns:com="http://schemas.openxmlformats.org/drawingml/2006/compatibility" xmlns:p14="http://schemas.microsoft.com/office/powerpoint/2010/main" xmlns:p15="http://schemas.microsoft.com/office/powerpoint/2012/main" xmlns:ahyp="http://schemas.microsoft.com/office/drawing/2018/hyperlinkcolor">
   <p:cSld>
     <p:bg>
@@ -8515,7 +9937,7 @@
     </p:bg>
     <p:spTree>
       <p:nvGrpSpPr>
-        <p:cNvPr id="162" name="Shape 162"/>
+        <p:cNvPr id="177" name="Shape 177"/>
         <p:cNvGrpSpPr/>
         <p:nvPr/>
       </p:nvGrpSpPr>
@@ -8529,7 +9951,7 @@
       </p:grpSpPr>
       <p:sp>
         <p:nvSpPr>
-          <p:cNvPr id="163" name="Google Shape;163;p16"/>
+          <p:cNvPr id="178" name="Google Shape;178;p16"/>
           <p:cNvSpPr/>
           <p:nvPr/>
         </p:nvSpPr>
@@ -8592,7 +10014,7 @@
       </p:sp>
       <p:pic>
         <p:nvPicPr>
-          <p:cNvPr descr="preencoded.png" id="164" name="Google Shape;164;p16"/>
+          <p:cNvPr descr="preencoded.png" id="179" name="Google Shape;179;p16"/>
           <p:cNvPicPr preferRelativeResize="0"/>
           <p:nvPr/>
         </p:nvPicPr>
@@ -8619,7 +10041,7 @@
       </p:pic>
       <p:sp>
         <p:nvSpPr>
-          <p:cNvPr id="165" name="Google Shape;165;p16"/>
+          <p:cNvPr id="180" name="Google Shape;180;p16"/>
           <p:cNvSpPr/>
           <p:nvPr/>
         </p:nvSpPr>
@@ -8688,7 +10110,7 @@
 </p:sld>
 </file>
 
-<file path=ppt/slides/slide16.xml><?xml version="1.0" encoding="utf-8"?>
+<file path=ppt/slides/slide18.xml><?xml version="1.0" encoding="utf-8"?>
 <p:sld xmlns:a="http://schemas.openxmlformats.org/drawingml/2006/main" xmlns:r="http://schemas.openxmlformats.org/officeDocument/2006/relationships" xmlns:mc="http://schemas.openxmlformats.org/markup-compatibility/2006" xmlns:mv="urn:schemas-microsoft-com:mac:vml" xmlns:p="http://schemas.openxmlformats.org/presentationml/2006/main" xmlns:c="http://schemas.openxmlformats.org/drawingml/2006/chart" xmlns:dgm="http://schemas.openxmlformats.org/drawingml/2006/diagram" xmlns:o="urn:schemas-microsoft-com:office:office" xmlns:v="urn:schemas-microsoft-com:vml" xmlns:pvml="urn:schemas-microsoft-com:office:powerpoint" xmlns:com="http://schemas.openxmlformats.org/drawingml/2006/compatibility" xmlns:p14="http://schemas.microsoft.com/office/powerpoint/2010/main" xmlns:p15="http://schemas.microsoft.com/office/powerpoint/2012/main" xmlns:ahyp="http://schemas.microsoft.com/office/drawing/2018/hyperlinkcolor">
   <p:cSld>
     <p:bg>
@@ -8700,7 +10122,7 @@
     </p:bg>
     <p:spTree>
       <p:nvGrpSpPr>
-        <p:cNvPr id="170" name="Shape 170"/>
+        <p:cNvPr id="185" name="Shape 185"/>
         <p:cNvGrpSpPr/>
         <p:nvPr/>
       </p:nvGrpSpPr>
@@ -8714,7 +10136,7 @@
       </p:grpSpPr>
       <p:sp>
         <p:nvSpPr>
-          <p:cNvPr id="171" name="Google Shape;171;p17"/>
+          <p:cNvPr id="186" name="Google Shape;186;p17"/>
           <p:cNvSpPr/>
           <p:nvPr/>
         </p:nvSpPr>
@@ -8777,7 +10199,7 @@
       </p:sp>
       <p:sp>
         <p:nvSpPr>
-          <p:cNvPr id="172" name="Google Shape;172;p17"/>
+          <p:cNvPr id="187" name="Google Shape;187;p17"/>
           <p:cNvSpPr/>
           <p:nvPr/>
         </p:nvSpPr>
@@ -8840,7 +10262,7 @@
       </p:sp>
       <p:pic>
         <p:nvPicPr>
-          <p:cNvPr descr="preencoded.png" id="173" name="Google Shape;173;p17"/>
+          <p:cNvPr descr="preencoded.png" id="188" name="Google Shape;188;p17"/>
           <p:cNvPicPr preferRelativeResize="0"/>
           <p:nvPr/>
         </p:nvPicPr>
@@ -8867,7 +10289,7 @@
       </p:pic>
       <p:sp>
         <p:nvSpPr>
-          <p:cNvPr id="174" name="Google Shape;174;p17"/>
+          <p:cNvPr id="189" name="Google Shape;189;p17"/>
           <p:cNvSpPr/>
           <p:nvPr/>
         </p:nvSpPr>
@@ -8890,7 +10312,7 @@
           </a:bodyPr>
           <a:lstStyle/>
           <a:p>
-            <a:pPr indent="0" lvl="0" marL="0" marR="0" rtl="0" algn="ctr">
+            <a:pPr indent="0" lvl="0" marL="0" rtl="0" algn="ctr">
               <a:spcBef>
                 <a:spcPts val="0"/>
               </a:spcBef>
@@ -8905,7 +10327,7 @@
               <a:buNone/>
             </a:pPr>
             <a:r>
-              <a:rPr b="1" i="0" lang="en-US" sz="1100" u="none" cap="none" strike="noStrike">
+              <a:rPr b="1" lang="en-US" sz="1100">
                 <a:solidFill>
                   <a:srgbClr val="64748B"/>
                 </a:solidFill>
@@ -8914,7 +10336,7 @@
                 <a:cs typeface="Calibri"/>
                 <a:sym typeface="Calibri"/>
               </a:rPr>
-              <a:t>Excluding Exit Actions (Topic ≠ D)</a:t>
+              <a:t>Excluding Topic D</a:t>
             </a:r>
             <a:endParaRPr b="0" i="0" sz="1100" u="none" cap="none" strike="noStrike">
               <a:solidFill>
@@ -8930,7 +10352,7 @@
       </p:sp>
       <p:pic>
         <p:nvPicPr>
-          <p:cNvPr descr="preencoded.png" id="175" name="Google Shape;175;p17"/>
+          <p:cNvPr descr="preencoded.png" id="190" name="Google Shape;190;p17"/>
           <p:cNvPicPr preferRelativeResize="0"/>
           <p:nvPr/>
         </p:nvPicPr>
@@ -8957,7 +10379,7 @@
       </p:pic>
       <p:sp>
         <p:nvSpPr>
-          <p:cNvPr id="176" name="Google Shape;176;p17"/>
+          <p:cNvPr id="191" name="Google Shape;191;p17"/>
           <p:cNvSpPr/>
           <p:nvPr/>
         </p:nvSpPr>
@@ -9026,7 +10448,7 @@
 </p:sld>
 </file>
 
-<file path=ppt/slides/slide17.xml><?xml version="1.0" encoding="utf-8"?>
+<file path=ppt/slides/slide19.xml><?xml version="1.0" encoding="utf-8"?>
 <p:sld xmlns:a="http://schemas.openxmlformats.org/drawingml/2006/main" xmlns:r="http://schemas.openxmlformats.org/officeDocument/2006/relationships" xmlns:mc="http://schemas.openxmlformats.org/markup-compatibility/2006" xmlns:mv="urn:schemas-microsoft-com:mac:vml" xmlns:p="http://schemas.openxmlformats.org/presentationml/2006/main" xmlns:c="http://schemas.openxmlformats.org/drawingml/2006/chart" xmlns:dgm="http://schemas.openxmlformats.org/drawingml/2006/diagram" xmlns:o="urn:schemas-microsoft-com:office:office" xmlns:v="urn:schemas-microsoft-com:vml" xmlns:pvml="urn:schemas-microsoft-com:office:powerpoint" xmlns:com="http://schemas.openxmlformats.org/drawingml/2006/compatibility" xmlns:p14="http://schemas.microsoft.com/office/powerpoint/2010/main" xmlns:p15="http://schemas.microsoft.com/office/powerpoint/2012/main" xmlns:ahyp="http://schemas.microsoft.com/office/drawing/2018/hyperlinkcolor">
   <p:cSld>
     <p:bg>
@@ -9038,7 +10460,7 @@
     </p:bg>
     <p:spTree>
       <p:nvGrpSpPr>
-        <p:cNvPr id="181" name="Shape 181"/>
+        <p:cNvPr id="196" name="Shape 196"/>
         <p:cNvGrpSpPr/>
         <p:nvPr/>
       </p:nvGrpSpPr>
@@ -9052,7 +10474,7 @@
       </p:grpSpPr>
       <p:sp>
         <p:nvSpPr>
-          <p:cNvPr id="182" name="Google Shape;182;p18"/>
+          <p:cNvPr id="197" name="Google Shape;197;p18"/>
           <p:cNvSpPr/>
           <p:nvPr/>
         </p:nvSpPr>
@@ -9115,7 +10537,7 @@
       </p:sp>
       <p:graphicFrame>
         <p:nvGraphicFramePr>
-          <p:cNvPr id="183" name="Google Shape;183;p18"/>
+          <p:cNvPr id="198" name="Google Shape;198;p18"/>
           <p:cNvGraphicFramePr/>
           <p:nvPr/>
         </p:nvGraphicFramePr>
@@ -9128,7 +10550,7 @@
             <a:tbl>
               <a:tblPr>
                 <a:noFill/>
-                <a:tableStyleId>{D5F6018F-751F-4F2E-BD67-FB7EB4D050E7}</a:tableStyleId>
+                <a:tableStyleId>{1FBCE98C-879A-4A73-B205-419AE505E898}</a:tableStyleId>
               </a:tblPr>
               <a:tblGrid>
                 <a:gridCol w="2286000"/>
@@ -10330,7 +11752,7 @@
       </p:graphicFrame>
       <p:sp>
         <p:nvSpPr>
-          <p:cNvPr id="184" name="Google Shape;184;p18"/>
+          <p:cNvPr id="199" name="Google Shape;199;p18"/>
           <p:cNvSpPr/>
           <p:nvPr/>
         </p:nvSpPr>
@@ -10393,7 +11815,7 @@
       </p:sp>
       <p:sp>
         <p:nvSpPr>
-          <p:cNvPr id="185" name="Google Shape;185;p18"/>
+          <p:cNvPr id="200" name="Google Shape;200;p18"/>
           <p:cNvSpPr/>
           <p:nvPr/>
         </p:nvSpPr>
@@ -10443,393 +11865,6 @@
               <a:t>All models evaluated over 1,000 episodes</a:t>
             </a:r>
             <a:endParaRPr b="0" i="0" sz="900" u="none" cap="none" strike="noStrike">
-              <a:solidFill>
-                <a:schemeClr val="dk1"/>
-              </a:solidFill>
-              <a:latin typeface="Calibri"/>
-              <a:ea typeface="Calibri"/>
-              <a:cs typeface="Calibri"/>
-              <a:sym typeface="Calibri"/>
-            </a:endParaRPr>
-          </a:p>
-        </p:txBody>
-      </p:sp>
-    </p:spTree>
-  </p:cSld>
-  <p:clrMapOvr>
-    <a:masterClrMapping/>
-  </p:clrMapOvr>
-</p:sld>
-</file>
-
-<file path=ppt/slides/slide18.xml><?xml version="1.0" encoding="utf-8"?>
-<p:sld xmlns:a="http://schemas.openxmlformats.org/drawingml/2006/main" xmlns:r="http://schemas.openxmlformats.org/officeDocument/2006/relationships" xmlns:mc="http://schemas.openxmlformats.org/markup-compatibility/2006" xmlns:mv="urn:schemas-microsoft-com:mac:vml" xmlns:p="http://schemas.openxmlformats.org/presentationml/2006/main" xmlns:c="http://schemas.openxmlformats.org/drawingml/2006/chart" xmlns:dgm="http://schemas.openxmlformats.org/drawingml/2006/diagram" xmlns:o="urn:schemas-microsoft-com:office:office" xmlns:v="urn:schemas-microsoft-com:vml" xmlns:pvml="urn:schemas-microsoft-com:office:powerpoint" xmlns:com="http://schemas.openxmlformats.org/drawingml/2006/compatibility" xmlns:p14="http://schemas.microsoft.com/office/powerpoint/2010/main" xmlns:p15="http://schemas.microsoft.com/office/powerpoint/2012/main" xmlns:ahyp="http://schemas.microsoft.com/office/drawing/2018/hyperlinkcolor">
-  <p:cSld>
-    <p:bg>
-      <p:bgPr>
-        <a:solidFill>
-          <a:srgbClr val="1E293B"/>
-        </a:solidFill>
-      </p:bgPr>
-    </p:bg>
-    <p:spTree>
-      <p:nvGrpSpPr>
-        <p:cNvPr id="190" name="Shape 190"/>
-        <p:cNvGrpSpPr/>
-        <p:nvPr/>
-      </p:nvGrpSpPr>
-      <p:grpSpPr>
-        <a:xfrm>
-          <a:off x="0" y="0"/>
-          <a:ext cx="0" cy="0"/>
-          <a:chOff x="0" y="0"/>
-          <a:chExt cx="0" cy="0"/>
-        </a:xfrm>
-      </p:grpSpPr>
-      <p:sp>
-        <p:nvSpPr>
-          <p:cNvPr id="191" name="Google Shape;191;p19"/>
-          <p:cNvSpPr/>
-          <p:nvPr/>
-        </p:nvSpPr>
-        <p:spPr>
-          <a:xfrm>
-            <a:off x="457200" y="274320"/>
-            <a:ext cx="8229600" cy="731520"/>
-          </a:xfrm>
-          <a:prstGeom prst="rect">
-            <a:avLst/>
-          </a:prstGeom>
-          <a:noFill/>
-          <a:ln>
-            <a:noFill/>
-          </a:ln>
-        </p:spPr>
-        <p:txBody>
-          <a:bodyPr anchorCtr="0" anchor="ctr" bIns="0" lIns="0" spcFirstLastPara="1" rIns="0" wrap="square" tIns="0">
-            <a:noAutofit/>
-          </a:bodyPr>
-          <a:lstStyle/>
-          <a:p>
-            <a:pPr indent="0" lvl="0" marL="0" marR="0" rtl="0" algn="l">
-              <a:spcBef>
-                <a:spcPts val="0"/>
-              </a:spcBef>
-              <a:spcAft>
-                <a:spcPts val="0"/>
-              </a:spcAft>
-              <a:buClr>
-                <a:srgbClr val="FFFFFF"/>
-              </a:buClr>
-              <a:buSzPts val="2800"/>
-              <a:buFont typeface="Trebuchet MS"/>
-              <a:buNone/>
-            </a:pPr>
-            <a:r>
-              <a:rPr b="1" i="0" lang="en-US" sz="2800" u="none" cap="none" strike="noStrike">
-                <a:solidFill>
-                  <a:srgbClr val="FFFFFF"/>
-                </a:solidFill>
-                <a:latin typeface="Trebuchet MS"/>
-                <a:ea typeface="Trebuchet MS"/>
-                <a:cs typeface="Trebuchet MS"/>
-                <a:sym typeface="Trebuchet MS"/>
-              </a:rPr>
-              <a:t>Key Takeaways</a:t>
-            </a:r>
-            <a:endParaRPr b="0" i="0" sz="2800" u="none" cap="none" strike="noStrike">
-              <a:solidFill>
-                <a:schemeClr val="dk1"/>
-              </a:solidFill>
-              <a:latin typeface="Calibri"/>
-              <a:ea typeface="Calibri"/>
-              <a:cs typeface="Calibri"/>
-              <a:sym typeface="Calibri"/>
-            </a:endParaRPr>
-          </a:p>
-        </p:txBody>
-      </p:sp>
-      <p:sp>
-        <p:nvSpPr>
-          <p:cNvPr id="192" name="Google Shape;192;p19"/>
-          <p:cNvSpPr/>
-          <p:nvPr/>
-        </p:nvSpPr>
-        <p:spPr>
-          <a:xfrm>
-            <a:off x="457200" y="1097280"/>
-            <a:ext cx="8229600" cy="3657600"/>
-          </a:xfrm>
-          <a:prstGeom prst="rect">
-            <a:avLst/>
-          </a:prstGeom>
-          <a:noFill/>
-          <a:ln>
-            <a:noFill/>
-          </a:ln>
-        </p:spPr>
-        <p:txBody>
-          <a:bodyPr anchorCtr="0" anchor="t" bIns="45700" lIns="91425" spcFirstLastPara="1" rIns="91425" wrap="square" tIns="45700">
-            <a:noAutofit/>
-          </a:bodyPr>
-          <a:lstStyle/>
-          <a:p>
-            <a:pPr indent="0" lvl="0" marL="0" marR="0" rtl="0" algn="l">
-              <a:spcBef>
-                <a:spcPts val="0"/>
-              </a:spcBef>
-              <a:spcAft>
-                <a:spcPts val="0"/>
-              </a:spcAft>
-              <a:buClr>
-                <a:srgbClr val="0891B2"/>
-              </a:buClr>
-              <a:buSzPts val="1600"/>
-              <a:buFont typeface="Trebuchet MS"/>
-              <a:buNone/>
-            </a:pPr>
-            <a:r>
-              <a:rPr b="1" i="0" lang="en-US" sz="1600" u="none" cap="none" strike="noStrike">
-                <a:solidFill>
-                  <a:srgbClr val="0891B2"/>
-                </a:solidFill>
-                <a:latin typeface="Trebuchet MS"/>
-                <a:ea typeface="Trebuchet MS"/>
-                <a:cs typeface="Trebuchet MS"/>
-                <a:sym typeface="Trebuchet MS"/>
-              </a:rPr>
-              <a:t>DQN outperforms A2C</a:t>
-            </a:r>
-            <a:endParaRPr b="0" i="0" sz="1600" u="none" cap="none" strike="noStrike">
-              <a:solidFill>
-                <a:schemeClr val="dk1"/>
-              </a:solidFill>
-              <a:latin typeface="Calibri"/>
-              <a:ea typeface="Calibri"/>
-              <a:cs typeface="Calibri"/>
-              <a:sym typeface="Calibri"/>
-            </a:endParaRPr>
-          </a:p>
-          <a:p>
-            <a:pPr indent="0" lvl="0" marL="0" marR="0" rtl="0" algn="l">
-              <a:spcBef>
-                <a:spcPts val="0"/>
-              </a:spcBef>
-              <a:spcAft>
-                <a:spcPts val="0"/>
-              </a:spcAft>
-              <a:buClr>
-                <a:srgbClr val="64748B"/>
-              </a:buClr>
-              <a:buSzPts val="1300"/>
-              <a:buFont typeface="Calibri"/>
-              <a:buNone/>
-            </a:pPr>
-            <a:r>
-              <a:rPr b="0" i="0" lang="en-US" sz="1300" u="none" cap="none" strike="noStrike">
-                <a:solidFill>
-                  <a:srgbClr val="64748B"/>
-                </a:solidFill>
-                <a:latin typeface="Calibri"/>
-                <a:ea typeface="Calibri"/>
-                <a:cs typeface="Calibri"/>
-                <a:sym typeface="Calibri"/>
-              </a:rPr>
-              <a:t>44.7% conversion rate vs 32.0% — DQN's experience replay and target network provide more stable learning in this environment.</a:t>
-            </a:r>
-            <a:br>
-              <a:rPr b="0" i="0" lang="en-US" sz="1300" u="none" cap="none" strike="noStrike">
-                <a:solidFill>
-                  <a:srgbClr val="64748B"/>
-                </a:solidFill>
-                <a:latin typeface="Calibri"/>
-                <a:ea typeface="Calibri"/>
-                <a:cs typeface="Calibri"/>
-                <a:sym typeface="Calibri"/>
-              </a:rPr>
-            </a:br>
-            <a:br>
-              <a:rPr b="0" i="0" lang="en-US" sz="1300" u="none" cap="none" strike="noStrike">
-                <a:solidFill>
-                  <a:srgbClr val="64748B"/>
-                </a:solidFill>
-                <a:latin typeface="Calibri"/>
-                <a:ea typeface="Calibri"/>
-                <a:cs typeface="Calibri"/>
-                <a:sym typeface="Calibri"/>
-              </a:rPr>
-            </a:br>
-            <a:endParaRPr b="0" i="0" sz="1600" u="none" cap="none" strike="noStrike">
-              <a:solidFill>
-                <a:schemeClr val="dk1"/>
-              </a:solidFill>
-              <a:latin typeface="Calibri"/>
-              <a:ea typeface="Calibri"/>
-              <a:cs typeface="Calibri"/>
-              <a:sym typeface="Calibri"/>
-            </a:endParaRPr>
-          </a:p>
-          <a:p>
-            <a:pPr indent="0" lvl="0" marL="0" marR="0" rtl="0" algn="l">
-              <a:spcBef>
-                <a:spcPts val="0"/>
-              </a:spcBef>
-              <a:spcAft>
-                <a:spcPts val="0"/>
-              </a:spcAft>
-              <a:buClr>
-                <a:srgbClr val="0891B2"/>
-              </a:buClr>
-              <a:buSzPts val="1600"/>
-              <a:buFont typeface="Trebuchet MS"/>
-              <a:buNone/>
-            </a:pPr>
-            <a:r>
-              <a:rPr b="1" i="0" lang="en-US" sz="1600" u="none" cap="none" strike="noStrike">
-                <a:solidFill>
-                  <a:srgbClr val="0891B2"/>
-                </a:solidFill>
-                <a:latin typeface="Trebuchet MS"/>
-                <a:ea typeface="Trebuchet MS"/>
-                <a:cs typeface="Trebuchet MS"/>
-                <a:sym typeface="Trebuchet MS"/>
-              </a:rPr>
-              <a:t>Longer negotiations improve outcomes</a:t>
-            </a:r>
-            <a:endParaRPr b="0" i="0" sz="1600" u="none" cap="none" strike="noStrike">
-              <a:solidFill>
-                <a:schemeClr val="dk1"/>
-              </a:solidFill>
-              <a:latin typeface="Calibri"/>
-              <a:ea typeface="Calibri"/>
-              <a:cs typeface="Calibri"/>
-              <a:sym typeface="Calibri"/>
-            </a:endParaRPr>
-          </a:p>
-          <a:p>
-            <a:pPr indent="0" lvl="0" marL="0" marR="0" rtl="0" algn="l">
-              <a:spcBef>
-                <a:spcPts val="0"/>
-              </a:spcBef>
-              <a:spcAft>
-                <a:spcPts val="0"/>
-              </a:spcAft>
-              <a:buClr>
-                <a:srgbClr val="64748B"/>
-              </a:buClr>
-              <a:buSzPts val="1300"/>
-              <a:buFont typeface="Calibri"/>
-              <a:buNone/>
-            </a:pPr>
-            <a:r>
-              <a:rPr b="0" i="0" lang="en-US" sz="1300" u="none" cap="none" strike="noStrike">
-                <a:solidFill>
-                  <a:srgbClr val="64748B"/>
-                </a:solidFill>
-                <a:latin typeface="Calibri"/>
-                <a:ea typeface="Calibri"/>
-                <a:cs typeface="Calibri"/>
-                <a:sym typeface="Calibri"/>
-              </a:rPr>
-              <a:t>Increasing the exit threshold from 5 to 7 rounds boosted DQN conversion from 44.7% to 46.0%, suggesting the agent benefits from additional interaction rounds.</a:t>
-            </a:r>
-            <a:br>
-              <a:rPr b="0" i="0" lang="en-US" sz="1300" u="none" cap="none" strike="noStrike">
-                <a:solidFill>
-                  <a:srgbClr val="64748B"/>
-                </a:solidFill>
-                <a:latin typeface="Calibri"/>
-                <a:ea typeface="Calibri"/>
-                <a:cs typeface="Calibri"/>
-                <a:sym typeface="Calibri"/>
-              </a:rPr>
-            </a:br>
-            <a:br>
-              <a:rPr b="0" i="0" lang="en-US" sz="1300" u="none" cap="none" strike="noStrike">
-                <a:solidFill>
-                  <a:srgbClr val="64748B"/>
-                </a:solidFill>
-                <a:latin typeface="Calibri"/>
-                <a:ea typeface="Calibri"/>
-                <a:cs typeface="Calibri"/>
-                <a:sym typeface="Calibri"/>
-              </a:rPr>
-            </a:br>
-            <a:endParaRPr b="0" i="0" sz="1600" u="none" cap="none" strike="noStrike">
-              <a:solidFill>
-                <a:schemeClr val="dk1"/>
-              </a:solidFill>
-              <a:latin typeface="Calibri"/>
-              <a:ea typeface="Calibri"/>
-              <a:cs typeface="Calibri"/>
-              <a:sym typeface="Calibri"/>
-            </a:endParaRPr>
-          </a:p>
-          <a:p>
-            <a:pPr indent="0" lvl="0" marL="0" marR="0" rtl="0" algn="l">
-              <a:spcBef>
-                <a:spcPts val="0"/>
-              </a:spcBef>
-              <a:spcAft>
-                <a:spcPts val="0"/>
-              </a:spcAft>
-              <a:buClr>
-                <a:srgbClr val="0891B2"/>
-              </a:buClr>
-              <a:buSzPts val="1600"/>
-              <a:buFont typeface="Trebuchet MS"/>
-              <a:buNone/>
-            </a:pPr>
-            <a:r>
-              <a:rPr b="1" i="0" lang="en-US" sz="1600" u="none" cap="none" strike="noStrike">
-                <a:solidFill>
-                  <a:srgbClr val="0891B2"/>
-                </a:solidFill>
-                <a:latin typeface="Trebuchet MS"/>
-                <a:ea typeface="Trebuchet MS"/>
-                <a:cs typeface="Trebuchet MS"/>
-                <a:sym typeface="Trebuchet MS"/>
-              </a:rPr>
-              <a:t>Action distribution reveals strategy differences</a:t>
-            </a:r>
-            <a:endParaRPr b="0" i="0" sz="1600" u="none" cap="none" strike="noStrike">
-              <a:solidFill>
-                <a:schemeClr val="dk1"/>
-              </a:solidFill>
-              <a:latin typeface="Calibri"/>
-              <a:ea typeface="Calibri"/>
-              <a:cs typeface="Calibri"/>
-              <a:sym typeface="Calibri"/>
-            </a:endParaRPr>
-          </a:p>
-          <a:p>
-            <a:pPr indent="0" lvl="0" marL="0" marR="0" rtl="0" algn="l">
-              <a:spcBef>
-                <a:spcPts val="0"/>
-              </a:spcBef>
-              <a:spcAft>
-                <a:spcPts val="0"/>
-              </a:spcAft>
-              <a:buClr>
-                <a:srgbClr val="64748B"/>
-              </a:buClr>
-              <a:buSzPts val="1300"/>
-              <a:buFont typeface="Calibri"/>
-              <a:buNone/>
-            </a:pPr>
-            <a:r>
-              <a:rPr b="0" i="0" lang="en-US" sz="1300" u="none" cap="none" strike="noStrike">
-                <a:solidFill>
-                  <a:srgbClr val="64748B"/>
-                </a:solidFill>
-                <a:latin typeface="Calibri"/>
-                <a:ea typeface="Calibri"/>
-                <a:cs typeface="Calibri"/>
-                <a:sym typeface="Calibri"/>
-              </a:rPr>
-              <a:t>Analyzing per-topic action distributions (excluding exit actions) shows how each model adapts its persuasion strategy to different customer objections.</a:t>
-            </a:r>
-            <a:endParaRPr b="0" i="0" sz="1600" u="none" cap="none" strike="noStrike">
               <a:solidFill>
                 <a:schemeClr val="dk1"/>
               </a:solidFill>
@@ -11565,20 +12600,20 @@
               <a:buNone/>
             </a:pPr>
             <a:r>
-              <a:rPr b="0" i="0" lang="en-US" sz="1600" u="none" cap="none" strike="noStrike">
+              <a:rPr lang="en-US" sz="1600">
                 <a:solidFill>
-                  <a:srgbClr val="64748B"/>
+                  <a:schemeClr val="lt1"/>
                 </a:solidFill>
                 <a:latin typeface="Calibri"/>
                 <a:ea typeface="Calibri"/>
                 <a:cs typeface="Calibri"/>
                 <a:sym typeface="Calibri"/>
               </a:rPr>
-              <a:t>Reward Distribution and Episode Length</a:t>
+              <a:t>Framework: Stable Baseline 3.</a:t>
             </a:r>
-            <a:endParaRPr b="0" i="0" sz="1600" u="none" cap="none" strike="noStrike">
+            <a:endParaRPr sz="1600">
               <a:solidFill>
-                <a:schemeClr val="dk1"/>
+                <a:schemeClr val="lt1"/>
               </a:solidFill>
               <a:latin typeface="Calibri"/>
               <a:ea typeface="Calibri"/>
@@ -11595,18 +12630,27 @@
                 <a:spcPts val="0"/>
               </a:spcAft>
               <a:buClr>
-                <a:schemeClr val="dk1"/>
+                <a:srgbClr val="64748B"/>
               </a:buClr>
               <a:buSzPts val="1600"/>
               <a:buFont typeface="Calibri"/>
               <a:buNone/>
             </a:pPr>
             <a:r>
-              <a:t/>
+              <a:rPr lang="en-US" sz="1600">
+                <a:solidFill>
+                  <a:schemeClr val="lt1"/>
+                </a:solidFill>
+                <a:latin typeface="Calibri"/>
+                <a:ea typeface="Calibri"/>
+                <a:cs typeface="Calibri"/>
+                <a:sym typeface="Calibri"/>
+              </a:rPr>
+              <a:t>Online Training with epsilon greedy sampling strategy.</a:t>
             </a:r>
-            <a:endParaRPr b="0" i="0" sz="1600" u="none" cap="none" strike="noStrike">
+            <a:endParaRPr sz="1600">
               <a:solidFill>
-                <a:schemeClr val="dk1"/>
+                <a:schemeClr val="lt1"/>
               </a:solidFill>
               <a:latin typeface="Calibri"/>
               <a:ea typeface="Calibri"/>
@@ -11630,20 +12674,20 @@
               <a:buNone/>
             </a:pPr>
             <a:r>
-              <a:rPr b="0" i="0" lang="en-US" sz="1600" u="none" cap="none" strike="noStrike">
+              <a:rPr lang="en-US" sz="1600">
                 <a:solidFill>
-                  <a:srgbClr val="64748B"/>
+                  <a:schemeClr val="lt1"/>
                 </a:solidFill>
                 <a:latin typeface="Calibri"/>
                 <a:ea typeface="Calibri"/>
                 <a:cs typeface="Calibri"/>
                 <a:sym typeface="Calibri"/>
               </a:rPr>
-              <a:t>We evaluate 1000 episodes using the best model selected by SB3.</a:t>
+              <a:t>Architecture: Q-net with 2 layer MLP [128, 64].</a:t>
             </a:r>
-            <a:endParaRPr b="0" i="0" sz="1600" u="none" cap="none" strike="noStrike">
+            <a:endParaRPr sz="1600">
               <a:solidFill>
-                <a:schemeClr val="dk1"/>
+                <a:schemeClr val="lt1"/>
               </a:solidFill>
               <a:latin typeface="Calibri"/>
               <a:ea typeface="Calibri"/>
@@ -12000,7 +13044,7 @@
             <a:tbl>
               <a:tblPr>
                 <a:noFill/>
-                <a:tableStyleId>{D5F6018F-751F-4F2E-BD67-FB7EB4D050E7}</a:tableStyleId>
+                <a:tableStyleId>{1FBCE98C-879A-4A73-B205-419AE505E898}</a:tableStyleId>
               </a:tblPr>
               <a:tblGrid>
                 <a:gridCol w="2263150"/>
@@ -15233,7 +16277,19 @@
                 <a:cs typeface="Calibri"/>
                 <a:sym typeface="Calibri"/>
               </a:rPr>
-              <a:t>Excluding Exit Actions (Topic ≠ D)</a:t>
+              <a:t>Excluding </a:t>
+            </a:r>
+            <a:r>
+              <a:rPr b="1" lang="en-US" sz="1100">
+                <a:solidFill>
+                  <a:srgbClr val="64748B"/>
+                </a:solidFill>
+                <a:latin typeface="Calibri"/>
+                <a:ea typeface="Calibri"/>
+                <a:cs typeface="Calibri"/>
+                <a:sym typeface="Calibri"/>
+              </a:rPr>
+              <a:t>Topic D</a:t>
             </a:r>
             <a:endParaRPr b="0" i="0" sz="1100" u="none" cap="none" strike="noStrike">
               <a:solidFill>
@@ -15371,7 +16427,462 @@
       </p:grpSpPr>
       <p:sp>
         <p:nvSpPr>
-          <p:cNvPr id="87" name="Google Shape;87;p9"/>
+          <p:cNvPr id="87" name="Google Shape;87;g395f996db06_0_36"/>
+          <p:cNvSpPr/>
+          <p:nvPr/>
+        </p:nvSpPr>
+        <p:spPr>
+          <a:xfrm>
+            <a:off x="457200" y="274320"/>
+            <a:ext cx="8229600" cy="731400"/>
+          </a:xfrm>
+          <a:prstGeom prst="rect">
+            <a:avLst/>
+          </a:prstGeom>
+          <a:noFill/>
+          <a:ln>
+            <a:noFill/>
+          </a:ln>
+        </p:spPr>
+        <p:txBody>
+          <a:bodyPr anchorCtr="0" anchor="ctr" bIns="0" lIns="0" spcFirstLastPara="1" rIns="0" wrap="square" tIns="0">
+            <a:noAutofit/>
+          </a:bodyPr>
+          <a:lstStyle/>
+          <a:p>
+            <a:pPr indent="0" lvl="0" marL="0" marR="0" rtl="0" algn="l">
+              <a:spcBef>
+                <a:spcPts val="0"/>
+              </a:spcBef>
+              <a:spcAft>
+                <a:spcPts val="0"/>
+              </a:spcAft>
+              <a:buClr>
+                <a:srgbClr val="FFFFFF"/>
+              </a:buClr>
+              <a:buSzPts val="2800"/>
+              <a:buFont typeface="Trebuchet MS"/>
+              <a:buNone/>
+            </a:pPr>
+            <a:r>
+              <a:rPr b="1" i="0" lang="en-US" sz="2800" u="none" cap="none" strike="noStrike">
+                <a:solidFill>
+                  <a:srgbClr val="FFFFFF"/>
+                </a:solidFill>
+                <a:latin typeface="Trebuchet MS"/>
+                <a:ea typeface="Trebuchet MS"/>
+                <a:cs typeface="Trebuchet MS"/>
+                <a:sym typeface="Trebuchet MS"/>
+              </a:rPr>
+              <a:t>Key Takeaways</a:t>
+            </a:r>
+            <a:endParaRPr b="0" i="0" sz="2800" u="none" cap="none" strike="noStrike">
+              <a:solidFill>
+                <a:schemeClr val="dk1"/>
+              </a:solidFill>
+              <a:latin typeface="Calibri"/>
+              <a:ea typeface="Calibri"/>
+              <a:cs typeface="Calibri"/>
+              <a:sym typeface="Calibri"/>
+            </a:endParaRPr>
+          </a:p>
+        </p:txBody>
+      </p:sp>
+      <p:sp>
+        <p:nvSpPr>
+          <p:cNvPr id="88" name="Google Shape;88;g395f996db06_0_36"/>
+          <p:cNvSpPr/>
+          <p:nvPr/>
+        </p:nvSpPr>
+        <p:spPr>
+          <a:xfrm>
+            <a:off x="457200" y="1097280"/>
+            <a:ext cx="8229600" cy="3657600"/>
+          </a:xfrm>
+          <a:prstGeom prst="rect">
+            <a:avLst/>
+          </a:prstGeom>
+          <a:noFill/>
+          <a:ln>
+            <a:noFill/>
+          </a:ln>
+        </p:spPr>
+        <p:txBody>
+          <a:bodyPr anchorCtr="0" anchor="t" bIns="45700" lIns="91425" spcFirstLastPara="1" rIns="91425" wrap="square" tIns="45700">
+            <a:noAutofit/>
+          </a:bodyPr>
+          <a:lstStyle/>
+          <a:p>
+            <a:pPr indent="0" lvl="0" marL="0" marR="0" rtl="0" algn="l">
+              <a:spcBef>
+                <a:spcPts val="0"/>
+              </a:spcBef>
+              <a:spcAft>
+                <a:spcPts val="0"/>
+              </a:spcAft>
+              <a:buClr>
+                <a:srgbClr val="64748B"/>
+              </a:buClr>
+              <a:buSzPts val="1300"/>
+              <a:buFont typeface="Calibri"/>
+              <a:buNone/>
+            </a:pPr>
+            <a:r>
+              <a:rPr b="1" lang="en-US" sz="1600">
+                <a:solidFill>
+                  <a:schemeClr val="lt1"/>
+                </a:solidFill>
+                <a:latin typeface="Trebuchet MS"/>
+                <a:ea typeface="Trebuchet MS"/>
+                <a:cs typeface="Trebuchet MS"/>
+                <a:sym typeface="Trebuchet MS"/>
+              </a:rPr>
+              <a:t>Objection Handling Strategy</a:t>
+            </a:r>
+            <a:endParaRPr b="1" sz="1600">
+              <a:solidFill>
+                <a:schemeClr val="lt1"/>
+              </a:solidFill>
+              <a:latin typeface="Trebuchet MS"/>
+              <a:ea typeface="Trebuchet MS"/>
+              <a:cs typeface="Trebuchet MS"/>
+              <a:sym typeface="Trebuchet MS"/>
+            </a:endParaRPr>
+          </a:p>
+          <a:p>
+            <a:pPr indent="0" lvl="0" marL="0" marR="0" rtl="0" algn="l">
+              <a:spcBef>
+                <a:spcPts val="0"/>
+              </a:spcBef>
+              <a:spcAft>
+                <a:spcPts val="0"/>
+              </a:spcAft>
+              <a:buClr>
+                <a:srgbClr val="64748B"/>
+              </a:buClr>
+              <a:buSzPts val="1300"/>
+              <a:buFont typeface="Calibri"/>
+              <a:buNone/>
+            </a:pPr>
+            <a:r>
+              <a:rPr lang="en-US" sz="1300">
+                <a:solidFill>
+                  <a:schemeClr val="lt1"/>
+                </a:solidFill>
+                <a:latin typeface="Calibri"/>
+                <a:ea typeface="Calibri"/>
+                <a:cs typeface="Calibri"/>
+                <a:sym typeface="Calibri"/>
+              </a:rPr>
+              <a:t>If objection is A/B/C: prioritize incentives. In particular, always use incentives for the first two rounds when possible.</a:t>
+            </a:r>
+            <a:endParaRPr sz="1300">
+              <a:solidFill>
+                <a:schemeClr val="lt1"/>
+              </a:solidFill>
+              <a:latin typeface="Calibri"/>
+              <a:ea typeface="Calibri"/>
+              <a:cs typeface="Calibri"/>
+              <a:sym typeface="Calibri"/>
+            </a:endParaRPr>
+          </a:p>
+          <a:p>
+            <a:pPr indent="0" lvl="0" marL="0" marR="0" rtl="0" algn="l">
+              <a:spcBef>
+                <a:spcPts val="0"/>
+              </a:spcBef>
+              <a:spcAft>
+                <a:spcPts val="0"/>
+              </a:spcAft>
+              <a:buClr>
+                <a:srgbClr val="64748B"/>
+              </a:buClr>
+              <a:buSzPts val="1300"/>
+              <a:buFont typeface="Calibri"/>
+              <a:buNone/>
+            </a:pPr>
+            <a:r>
+              <a:rPr lang="en-US" sz="1300">
+                <a:solidFill>
+                  <a:schemeClr val="lt1"/>
+                </a:solidFill>
+                <a:latin typeface="Calibri"/>
+                <a:ea typeface="Calibri"/>
+                <a:cs typeface="Calibri"/>
+                <a:sym typeface="Calibri"/>
+              </a:rPr>
+              <a:t>If objection is D and round &lt; 5, persuade. If round &gt;= 5: enforce close.</a:t>
+            </a:r>
+            <a:endParaRPr sz="1300">
+              <a:solidFill>
+                <a:schemeClr val="lt1"/>
+              </a:solidFill>
+              <a:latin typeface="Calibri"/>
+              <a:ea typeface="Calibri"/>
+              <a:cs typeface="Calibri"/>
+              <a:sym typeface="Calibri"/>
+            </a:endParaRPr>
+          </a:p>
+          <a:p>
+            <a:pPr indent="0" lvl="0" marL="0" marR="0" rtl="0" algn="l">
+              <a:spcBef>
+                <a:spcPts val="0"/>
+              </a:spcBef>
+              <a:spcAft>
+                <a:spcPts val="0"/>
+              </a:spcAft>
+              <a:buClr>
+                <a:srgbClr val="64748B"/>
+              </a:buClr>
+              <a:buSzPts val="1300"/>
+              <a:buFont typeface="Calibri"/>
+              <a:buNone/>
+            </a:pPr>
+            <a:r>
+              <a:t/>
+            </a:r>
+            <a:endParaRPr sz="1300">
+              <a:solidFill>
+                <a:schemeClr val="lt1"/>
+              </a:solidFill>
+              <a:latin typeface="Calibri"/>
+              <a:ea typeface="Calibri"/>
+              <a:cs typeface="Calibri"/>
+              <a:sym typeface="Calibri"/>
+            </a:endParaRPr>
+          </a:p>
+          <a:p>
+            <a:pPr indent="0" lvl="0" marL="0" rtl="0" algn="l">
+              <a:spcBef>
+                <a:spcPts val="0"/>
+              </a:spcBef>
+              <a:spcAft>
+                <a:spcPts val="0"/>
+              </a:spcAft>
+              <a:buClr>
+                <a:srgbClr val="64748B"/>
+              </a:buClr>
+              <a:buSzPts val="1300"/>
+              <a:buFont typeface="Calibri"/>
+              <a:buNone/>
+            </a:pPr>
+            <a:r>
+              <a:rPr b="1" lang="en-US" sz="1600">
+                <a:solidFill>
+                  <a:schemeClr val="lt1"/>
+                </a:solidFill>
+                <a:latin typeface="Trebuchet MS"/>
+                <a:ea typeface="Trebuchet MS"/>
+                <a:cs typeface="Trebuchet MS"/>
+                <a:sym typeface="Trebuchet MS"/>
+              </a:rPr>
+              <a:t>Early Closing</a:t>
+            </a:r>
+            <a:endParaRPr b="1" sz="1600">
+              <a:solidFill>
+                <a:schemeClr val="lt1"/>
+              </a:solidFill>
+              <a:latin typeface="Trebuchet MS"/>
+              <a:ea typeface="Trebuchet MS"/>
+              <a:cs typeface="Trebuchet MS"/>
+              <a:sym typeface="Trebuchet MS"/>
+            </a:endParaRPr>
+          </a:p>
+          <a:p>
+            <a:pPr indent="0" lvl="0" marL="0" rtl="0" algn="l">
+              <a:spcBef>
+                <a:spcPts val="0"/>
+              </a:spcBef>
+              <a:spcAft>
+                <a:spcPts val="0"/>
+              </a:spcAft>
+              <a:buClr>
+                <a:srgbClr val="64748B"/>
+              </a:buClr>
+              <a:buSzPts val="1300"/>
+              <a:buFont typeface="Calibri"/>
+              <a:buNone/>
+            </a:pPr>
+            <a:r>
+              <a:rPr lang="en-US" sz="1300">
+                <a:solidFill>
+                  <a:schemeClr val="lt1"/>
+                </a:solidFill>
+                <a:latin typeface="Calibri"/>
+                <a:ea typeface="Calibri"/>
+                <a:cs typeface="Calibri"/>
+                <a:sym typeface="Calibri"/>
+              </a:rPr>
+              <a:t>If objection is A/B/C: closing starting at round 5 (moderately), enforce closing at round 6 and after.</a:t>
+            </a:r>
+            <a:endParaRPr sz="1300">
+              <a:solidFill>
+                <a:schemeClr val="lt1"/>
+              </a:solidFill>
+              <a:latin typeface="Calibri"/>
+              <a:ea typeface="Calibri"/>
+              <a:cs typeface="Calibri"/>
+              <a:sym typeface="Calibri"/>
+            </a:endParaRPr>
+          </a:p>
+          <a:p>
+            <a:pPr indent="0" lvl="0" marL="0" rtl="0" algn="l">
+              <a:spcBef>
+                <a:spcPts val="0"/>
+              </a:spcBef>
+              <a:spcAft>
+                <a:spcPts val="0"/>
+              </a:spcAft>
+              <a:buClr>
+                <a:srgbClr val="64748B"/>
+              </a:buClr>
+              <a:buSzPts val="1300"/>
+              <a:buFont typeface="Calibri"/>
+              <a:buNone/>
+            </a:pPr>
+            <a:r>
+              <a:rPr lang="en-US" sz="1300">
+                <a:solidFill>
+                  <a:schemeClr val="lt1"/>
+                </a:solidFill>
+                <a:latin typeface="Calibri"/>
+                <a:ea typeface="Calibri"/>
+                <a:cs typeface="Calibri"/>
+                <a:sym typeface="Calibri"/>
+              </a:rPr>
+              <a:t>If objection is D, moderate closing at round 4, enforce at round 5 and after.</a:t>
+            </a:r>
+            <a:endParaRPr sz="1300">
+              <a:solidFill>
+                <a:schemeClr val="lt1"/>
+              </a:solidFill>
+              <a:latin typeface="Calibri"/>
+              <a:ea typeface="Calibri"/>
+              <a:cs typeface="Calibri"/>
+              <a:sym typeface="Calibri"/>
+            </a:endParaRPr>
+          </a:p>
+          <a:p>
+            <a:pPr indent="0" lvl="0" marL="0" rtl="0" algn="l">
+              <a:spcBef>
+                <a:spcPts val="0"/>
+              </a:spcBef>
+              <a:spcAft>
+                <a:spcPts val="0"/>
+              </a:spcAft>
+              <a:buClr>
+                <a:srgbClr val="64748B"/>
+              </a:buClr>
+              <a:buSzPts val="1300"/>
+              <a:buFont typeface="Calibri"/>
+              <a:buNone/>
+            </a:pPr>
+            <a:r>
+              <a:t/>
+            </a:r>
+            <a:endParaRPr b="1" sz="1600">
+              <a:solidFill>
+                <a:schemeClr val="lt1"/>
+              </a:solidFill>
+              <a:latin typeface="Trebuchet MS"/>
+              <a:ea typeface="Trebuchet MS"/>
+              <a:cs typeface="Trebuchet MS"/>
+              <a:sym typeface="Trebuchet MS"/>
+            </a:endParaRPr>
+          </a:p>
+          <a:p>
+            <a:pPr indent="0" lvl="0" marL="0" rtl="0" algn="l">
+              <a:spcBef>
+                <a:spcPts val="0"/>
+              </a:spcBef>
+              <a:spcAft>
+                <a:spcPts val="0"/>
+              </a:spcAft>
+              <a:buClr>
+                <a:srgbClr val="64748B"/>
+              </a:buClr>
+              <a:buSzPts val="1300"/>
+              <a:buFont typeface="Calibri"/>
+              <a:buNone/>
+            </a:pPr>
+            <a:r>
+              <a:t/>
+            </a:r>
+            <a:endParaRPr b="1" sz="1600">
+              <a:solidFill>
+                <a:schemeClr val="lt1"/>
+              </a:solidFill>
+              <a:latin typeface="Trebuchet MS"/>
+              <a:ea typeface="Trebuchet MS"/>
+              <a:cs typeface="Trebuchet MS"/>
+              <a:sym typeface="Trebuchet MS"/>
+            </a:endParaRPr>
+          </a:p>
+          <a:p>
+            <a:pPr indent="0" lvl="0" marL="0" marR="0" rtl="0" algn="l">
+              <a:spcBef>
+                <a:spcPts val="0"/>
+              </a:spcBef>
+              <a:spcAft>
+                <a:spcPts val="0"/>
+              </a:spcAft>
+              <a:buClr>
+                <a:srgbClr val="64748B"/>
+              </a:buClr>
+              <a:buSzPts val="1300"/>
+              <a:buFont typeface="Calibri"/>
+              <a:buNone/>
+            </a:pPr>
+            <a:r>
+              <a:t/>
+            </a:r>
+            <a:endParaRPr sz="1600">
+              <a:solidFill>
+                <a:schemeClr val="lt1"/>
+              </a:solidFill>
+              <a:latin typeface="Calibri"/>
+              <a:ea typeface="Calibri"/>
+              <a:cs typeface="Calibri"/>
+              <a:sym typeface="Calibri"/>
+            </a:endParaRPr>
+          </a:p>
+        </p:txBody>
+      </p:sp>
+    </p:spTree>
+  </p:cSld>
+  <p:clrMapOvr>
+    <a:masterClrMapping/>
+  </p:clrMapOvr>
+</p:sld>
+</file>
+
+<file path=ppt/slides/slide9.xml><?xml version="1.0" encoding="utf-8"?>
+<p:sld xmlns:a="http://schemas.openxmlformats.org/drawingml/2006/main" xmlns:r="http://schemas.openxmlformats.org/officeDocument/2006/relationships" xmlns:mc="http://schemas.openxmlformats.org/markup-compatibility/2006" xmlns:mv="urn:schemas-microsoft-com:mac:vml" xmlns:p="http://schemas.openxmlformats.org/presentationml/2006/main" xmlns:c="http://schemas.openxmlformats.org/drawingml/2006/chart" xmlns:dgm="http://schemas.openxmlformats.org/drawingml/2006/diagram" xmlns:o="urn:schemas-microsoft-com:office:office" xmlns:v="urn:schemas-microsoft-com:vml" xmlns:pvml="urn:schemas-microsoft-com:office:powerpoint" xmlns:com="http://schemas.openxmlformats.org/drawingml/2006/compatibility" xmlns:p14="http://schemas.microsoft.com/office/powerpoint/2010/main" xmlns:p15="http://schemas.microsoft.com/office/powerpoint/2012/main" xmlns:ahyp="http://schemas.microsoft.com/office/drawing/2018/hyperlinkcolor">
+  <p:cSld>
+    <p:bg>
+      <p:bgPr>
+        <a:solidFill>
+          <a:srgbClr val="1E293B"/>
+        </a:solidFill>
+      </p:bgPr>
+    </p:bg>
+    <p:spTree>
+      <p:nvGrpSpPr>
+        <p:cNvPr id="93" name="Shape 93"/>
+        <p:cNvGrpSpPr/>
+        <p:nvPr/>
+      </p:nvGrpSpPr>
+      <p:grpSpPr>
+        <a:xfrm>
+          <a:off x="0" y="0"/>
+          <a:ext cx="0" cy="0"/>
+          <a:chOff x="0" y="0"/>
+          <a:chExt cx="0" cy="0"/>
+        </a:xfrm>
+      </p:grpSpPr>
+      <p:sp>
+        <p:nvSpPr>
+          <p:cNvPr id="94" name="Google Shape;94;p9"/>
           <p:cNvSpPr/>
           <p:nvPr/>
         </p:nvSpPr>
@@ -15414,7 +16925,7 @@
       </p:sp>
       <p:sp>
         <p:nvSpPr>
-          <p:cNvPr id="88" name="Google Shape;88;p9"/>
+          <p:cNvPr id="95" name="Google Shape;95;p9"/>
           <p:cNvSpPr/>
           <p:nvPr/>
         </p:nvSpPr>
@@ -15475,48 +16986,16 @@
           </a:p>
         </p:txBody>
       </p:sp>
-    </p:spTree>
-  </p:cSld>
-  <p:clrMapOvr>
-    <a:masterClrMapping/>
-  </p:clrMapOvr>
-</p:sld>
-</file>
-
-<file path=ppt/slides/slide9.xml><?xml version="1.0" encoding="utf-8"?>
-<p:sld xmlns:a="http://schemas.openxmlformats.org/drawingml/2006/main" xmlns:r="http://schemas.openxmlformats.org/officeDocument/2006/relationships" xmlns:mc="http://schemas.openxmlformats.org/markup-compatibility/2006" xmlns:mv="urn:schemas-microsoft-com:mac:vml" xmlns:p="http://schemas.openxmlformats.org/presentationml/2006/main" xmlns:c="http://schemas.openxmlformats.org/drawingml/2006/chart" xmlns:dgm="http://schemas.openxmlformats.org/drawingml/2006/diagram" xmlns:o="urn:schemas-microsoft-com:office:office" xmlns:v="urn:schemas-microsoft-com:vml" xmlns:pvml="urn:schemas-microsoft-com:office:powerpoint" xmlns:com="http://schemas.openxmlformats.org/drawingml/2006/compatibility" xmlns:p14="http://schemas.microsoft.com/office/powerpoint/2010/main" xmlns:p15="http://schemas.microsoft.com/office/powerpoint/2012/main" xmlns:ahyp="http://schemas.microsoft.com/office/drawing/2018/hyperlinkcolor">
-  <p:cSld>
-    <p:bg>
-      <p:bgPr>
-        <a:solidFill>
-          <a:srgbClr val="F1F5F9"/>
-        </a:solidFill>
-      </p:bgPr>
-    </p:bg>
-    <p:spTree>
-      <p:nvGrpSpPr>
-        <p:cNvPr id="93" name="Shape 93"/>
-        <p:cNvGrpSpPr/>
-        <p:nvPr/>
-      </p:nvGrpSpPr>
-      <p:grpSpPr>
-        <a:xfrm>
-          <a:off x="0" y="0"/>
-          <a:ext cx="0" cy="0"/>
-          <a:chOff x="0" y="0"/>
-          <a:chExt cx="0" cy="0"/>
-        </a:xfrm>
-      </p:grpSpPr>
       <p:sp>
         <p:nvSpPr>
-          <p:cNvPr id="94" name="Google Shape;94;g395f996db06_0_0"/>
+          <p:cNvPr id="96" name="Google Shape;96;p9"/>
           <p:cNvSpPr/>
           <p:nvPr/>
         </p:nvSpPr>
         <p:spPr>
           <a:xfrm>
-            <a:off x="457200" y="274320"/>
-            <a:ext cx="8229600" cy="640200"/>
+            <a:off x="457200" y="3202630"/>
+            <a:ext cx="7315200" cy="731400"/>
           </a:xfrm>
           <a:prstGeom prst="rect">
             <a:avLst/>
@@ -15540,729 +17019,51 @@
                 <a:spcPts val="0"/>
               </a:spcAft>
               <a:buClr>
-                <a:srgbClr val="1E293B"/>
+                <a:srgbClr val="64748B"/>
               </a:buClr>
-              <a:buSzPts val="2400"/>
-              <a:buFont typeface="Trebuchet MS"/>
+              <a:buSzPts val="1600"/>
+              <a:buFont typeface="Calibri"/>
               <a:buNone/>
             </a:pPr>
             <a:r>
-              <a:rPr b="1" i="0" lang="en-US" sz="2400" u="none" cap="none" strike="noStrike">
+              <a:rPr lang="en-US" sz="1600">
                 <a:solidFill>
-                  <a:srgbClr val="1E293B"/>
-                </a:solidFill>
-                <a:latin typeface="Trebuchet MS"/>
-                <a:ea typeface="Trebuchet MS"/>
-                <a:cs typeface="Trebuchet MS"/>
-                <a:sym typeface="Trebuchet MS"/>
-              </a:rPr>
-              <a:t>DQN — Results</a:t>
-            </a:r>
-            <a:endParaRPr b="0" i="0" sz="2400" u="none" cap="none" strike="noStrike">
-              <a:solidFill>
-                <a:schemeClr val="dk1"/>
-              </a:solidFill>
-              <a:latin typeface="Calibri"/>
-              <a:ea typeface="Calibri"/>
-              <a:cs typeface="Calibri"/>
-              <a:sym typeface="Calibri"/>
-            </a:endParaRPr>
-          </a:p>
-        </p:txBody>
-      </p:sp>
-      <p:sp>
-        <p:nvSpPr>
-          <p:cNvPr id="95" name="Google Shape;95;g395f996db06_0_0"/>
-          <p:cNvSpPr/>
-          <p:nvPr/>
-        </p:nvSpPr>
-        <p:spPr>
-          <a:xfrm>
-            <a:off x="457200" y="1188720"/>
-            <a:ext cx="2560200" cy="1463100"/>
-          </a:xfrm>
-          <a:prstGeom prst="rect">
-            <a:avLst/>
-          </a:prstGeom>
-          <a:solidFill>
-            <a:srgbClr val="FFFFFF"/>
-          </a:solidFill>
-          <a:ln>
-            <a:noFill/>
-          </a:ln>
-          <a:effectLst>
-            <a:outerShdw blurRad="76200" rotWithShape="0" algn="bl" dir="8100000" dist="25400">
-              <a:srgbClr val="000000">
-                <a:alpha val="7840"/>
-              </a:srgbClr>
-            </a:outerShdw>
-          </a:effectLst>
-        </p:spPr>
-        <p:txBody>
-          <a:bodyPr anchorCtr="0" anchor="ctr" bIns="91425" lIns="91425" spcFirstLastPara="1" rIns="91425" wrap="square" tIns="91425">
-            <a:noAutofit/>
-          </a:bodyPr>
-          <a:lstStyle/>
-          <a:p>
-            <a:pPr indent="0" lvl="0" marL="0" rtl="0" algn="l">
-              <a:spcBef>
-                <a:spcPts val="0"/>
-              </a:spcBef>
-              <a:spcAft>
-                <a:spcPts val="0"/>
-              </a:spcAft>
-              <a:buNone/>
-            </a:pPr>
-            <a:r>
-              <a:t/>
-            </a:r>
-            <a:endParaRPr/>
-          </a:p>
-        </p:txBody>
-      </p:sp>
-      <p:sp>
-        <p:nvSpPr>
-          <p:cNvPr id="96" name="Google Shape;96;g395f996db06_0_0"/>
-          <p:cNvSpPr/>
-          <p:nvPr/>
-        </p:nvSpPr>
-        <p:spPr>
-          <a:xfrm>
-            <a:off x="457200" y="1325880"/>
-            <a:ext cx="2560200" cy="822900"/>
-          </a:xfrm>
-          <a:prstGeom prst="rect">
-            <a:avLst/>
-          </a:prstGeom>
-          <a:noFill/>
-          <a:ln>
-            <a:noFill/>
-          </a:ln>
-        </p:spPr>
-        <p:txBody>
-          <a:bodyPr anchorCtr="0" anchor="ctr" bIns="0" lIns="0" spcFirstLastPara="1" rIns="0" wrap="square" tIns="0">
-            <a:noAutofit/>
-          </a:bodyPr>
-          <a:lstStyle/>
-          <a:p>
-            <a:pPr indent="0" lvl="0" marL="0" marR="0" rtl="0" algn="ctr">
-              <a:spcBef>
-                <a:spcPts val="0"/>
-              </a:spcBef>
-              <a:spcAft>
-                <a:spcPts val="0"/>
-              </a:spcAft>
-              <a:buClr>
-                <a:srgbClr val="0891B2"/>
-              </a:buClr>
-              <a:buSzPts val="4400"/>
-              <a:buFont typeface="Trebuchet MS"/>
-              <a:buNone/>
-            </a:pPr>
-            <a:r>
-              <a:rPr b="1" i="0" lang="en-US" sz="4400" u="none" cap="none" strike="noStrike">
-                <a:solidFill>
-                  <a:srgbClr val="0891B2"/>
-                </a:solidFill>
-                <a:latin typeface="Trebuchet MS"/>
-                <a:ea typeface="Trebuchet MS"/>
-                <a:cs typeface="Trebuchet MS"/>
-                <a:sym typeface="Trebuchet MS"/>
-              </a:rPr>
-              <a:t>4</a:t>
-            </a:r>
-            <a:r>
-              <a:rPr b="1" lang="en-US" sz="4400">
-                <a:solidFill>
-                  <a:srgbClr val="0891B2"/>
-                </a:solidFill>
-                <a:latin typeface="Trebuchet MS"/>
-                <a:ea typeface="Trebuchet MS"/>
-                <a:cs typeface="Trebuchet MS"/>
-                <a:sym typeface="Trebuchet MS"/>
-              </a:rPr>
-              <a:t>6.0</a:t>
-            </a:r>
-            <a:r>
-              <a:rPr b="1" i="0" lang="en-US" sz="4400" u="none" cap="none" strike="noStrike">
-                <a:solidFill>
-                  <a:srgbClr val="0891B2"/>
-                </a:solidFill>
-                <a:latin typeface="Trebuchet MS"/>
-                <a:ea typeface="Trebuchet MS"/>
-                <a:cs typeface="Trebuchet MS"/>
-                <a:sym typeface="Trebuchet MS"/>
-              </a:rPr>
-              <a:t>%</a:t>
-            </a:r>
-            <a:endParaRPr b="0" i="0" sz="4400" u="none" cap="none" strike="noStrike">
-              <a:solidFill>
-                <a:schemeClr val="dk1"/>
-              </a:solidFill>
-              <a:latin typeface="Calibri"/>
-              <a:ea typeface="Calibri"/>
-              <a:cs typeface="Calibri"/>
-              <a:sym typeface="Calibri"/>
-            </a:endParaRPr>
-          </a:p>
-        </p:txBody>
-      </p:sp>
-      <p:sp>
-        <p:nvSpPr>
-          <p:cNvPr id="97" name="Google Shape;97;g395f996db06_0_0"/>
-          <p:cNvSpPr/>
-          <p:nvPr/>
-        </p:nvSpPr>
-        <p:spPr>
-          <a:xfrm>
-            <a:off x="457200" y="2148840"/>
-            <a:ext cx="2560200" cy="365700"/>
-          </a:xfrm>
-          <a:prstGeom prst="rect">
-            <a:avLst/>
-          </a:prstGeom>
-          <a:noFill/>
-          <a:ln>
-            <a:noFill/>
-          </a:ln>
-        </p:spPr>
-        <p:txBody>
-          <a:bodyPr anchorCtr="0" anchor="ctr" bIns="0" lIns="0" spcFirstLastPara="1" rIns="0" wrap="square" tIns="0">
-            <a:noAutofit/>
-          </a:bodyPr>
-          <a:lstStyle/>
-          <a:p>
-            <a:pPr indent="0" lvl="0" marL="0" marR="0" rtl="0" algn="ctr">
-              <a:spcBef>
-                <a:spcPts val="0"/>
-              </a:spcBef>
-              <a:spcAft>
-                <a:spcPts val="0"/>
-              </a:spcAft>
-              <a:buClr>
-                <a:srgbClr val="64748B"/>
-              </a:buClr>
-              <a:buSzPts val="1200"/>
-              <a:buFont typeface="Calibri"/>
-              <a:buNone/>
-            </a:pPr>
-            <a:r>
-              <a:rPr b="0" i="0" lang="en-US" sz="1200" u="none" cap="none" strike="noStrike">
-                <a:solidFill>
-                  <a:srgbClr val="64748B"/>
+                  <a:schemeClr val="lt1"/>
                 </a:solidFill>
                 <a:latin typeface="Calibri"/>
                 <a:ea typeface="Calibri"/>
                 <a:cs typeface="Calibri"/>
                 <a:sym typeface="Calibri"/>
               </a:rPr>
-              <a:t>Conversion Rate</a:t>
-            </a:r>
-            <a:endParaRPr b="0" i="0" sz="1200" u="none" cap="none" strike="noStrike">
-              <a:solidFill>
-                <a:schemeClr val="dk1"/>
-              </a:solidFill>
-              <a:latin typeface="Calibri"/>
-              <a:ea typeface="Calibri"/>
-              <a:cs typeface="Calibri"/>
-              <a:sym typeface="Calibri"/>
-            </a:endParaRPr>
-          </a:p>
-        </p:txBody>
-      </p:sp>
-      <p:sp>
-        <p:nvSpPr>
-          <p:cNvPr id="98" name="Google Shape;98;g395f996db06_0_0"/>
-          <p:cNvSpPr/>
-          <p:nvPr/>
-        </p:nvSpPr>
-        <p:spPr>
-          <a:xfrm>
-            <a:off x="3291840" y="1188720"/>
-            <a:ext cx="2560200" cy="1463100"/>
-          </a:xfrm>
-          <a:prstGeom prst="rect">
-            <a:avLst/>
-          </a:prstGeom>
-          <a:solidFill>
-            <a:srgbClr val="FFFFFF"/>
-          </a:solidFill>
-          <a:ln>
-            <a:noFill/>
-          </a:ln>
-          <a:effectLst>
-            <a:outerShdw blurRad="76200" rotWithShape="0" algn="bl" dir="8100000" dist="25400">
-              <a:srgbClr val="000000">
-                <a:alpha val="7840"/>
-              </a:srgbClr>
-            </a:outerShdw>
-          </a:effectLst>
-        </p:spPr>
-        <p:txBody>
-          <a:bodyPr anchorCtr="0" anchor="ctr" bIns="91425" lIns="91425" spcFirstLastPara="1" rIns="91425" wrap="square" tIns="91425">
-            <a:noAutofit/>
-          </a:bodyPr>
-          <a:lstStyle/>
-          <a:p>
-            <a:pPr indent="0" lvl="0" marL="0" rtl="0" algn="l">
-              <a:spcBef>
-                <a:spcPts val="0"/>
-              </a:spcBef>
-              <a:spcAft>
-                <a:spcPts val="0"/>
-              </a:spcAft>
-              <a:buNone/>
-            </a:pPr>
-            <a:r>
-              <a:t/>
-            </a:r>
-            <a:endParaRPr/>
-          </a:p>
-        </p:txBody>
-      </p:sp>
-      <p:sp>
-        <p:nvSpPr>
-          <p:cNvPr id="99" name="Google Shape;99;g395f996db06_0_0"/>
-          <p:cNvSpPr/>
-          <p:nvPr/>
-        </p:nvSpPr>
-        <p:spPr>
-          <a:xfrm>
-            <a:off x="3291840" y="1325880"/>
-            <a:ext cx="2560200" cy="822900"/>
-          </a:xfrm>
-          <a:prstGeom prst="rect">
-            <a:avLst/>
-          </a:prstGeom>
-          <a:noFill/>
-          <a:ln>
-            <a:noFill/>
-          </a:ln>
-        </p:spPr>
-        <p:txBody>
-          <a:bodyPr anchorCtr="0" anchor="ctr" bIns="0" lIns="0" spcFirstLastPara="1" rIns="0" wrap="square" tIns="0">
-            <a:noAutofit/>
-          </a:bodyPr>
-          <a:lstStyle/>
-          <a:p>
-            <a:pPr indent="0" lvl="0" marL="0" marR="0" rtl="0" algn="ctr">
-              <a:spcBef>
-                <a:spcPts val="0"/>
-              </a:spcBef>
-              <a:spcAft>
-                <a:spcPts val="0"/>
-              </a:spcAft>
-              <a:buClr>
-                <a:srgbClr val="0891B2"/>
-              </a:buClr>
-              <a:buSzPts val="4400"/>
-              <a:buFont typeface="Trebuchet MS"/>
-              <a:buNone/>
-            </a:pPr>
-            <a:r>
-              <a:rPr b="1" i="0" lang="en-US" sz="4400" u="none" cap="none" strike="noStrike">
-                <a:solidFill>
-                  <a:srgbClr val="0891B2"/>
-                </a:solidFill>
-                <a:latin typeface="Trebuchet MS"/>
-                <a:ea typeface="Trebuchet MS"/>
-                <a:cs typeface="Trebuchet MS"/>
-                <a:sym typeface="Trebuchet MS"/>
-              </a:rPr>
-              <a:t>1.</a:t>
+              <a:t>Same model architecture, </a:t>
             </a:r>
             <a:r>
-              <a:rPr b="1" lang="en-US" sz="4400">
+              <a:rPr lang="en-US" sz="1600">
                 <a:solidFill>
-                  <a:srgbClr val="0891B2"/>
-                </a:solidFill>
-                <a:latin typeface="Trebuchet MS"/>
-                <a:ea typeface="Trebuchet MS"/>
-                <a:cs typeface="Trebuchet MS"/>
-                <a:sym typeface="Trebuchet MS"/>
-              </a:rPr>
-              <a:t>66</a:t>
-            </a:r>
-            <a:endParaRPr b="0" i="0" sz="4400" u="none" cap="none" strike="noStrike">
-              <a:solidFill>
-                <a:schemeClr val="dk1"/>
-              </a:solidFill>
-              <a:latin typeface="Calibri"/>
-              <a:ea typeface="Calibri"/>
-              <a:cs typeface="Calibri"/>
-              <a:sym typeface="Calibri"/>
-            </a:endParaRPr>
-          </a:p>
-        </p:txBody>
-      </p:sp>
-      <p:sp>
-        <p:nvSpPr>
-          <p:cNvPr id="100" name="Google Shape;100;g395f996db06_0_0"/>
-          <p:cNvSpPr/>
-          <p:nvPr/>
-        </p:nvSpPr>
-        <p:spPr>
-          <a:xfrm>
-            <a:off x="3291840" y="2148840"/>
-            <a:ext cx="2560200" cy="365700"/>
-          </a:xfrm>
-          <a:prstGeom prst="rect">
-            <a:avLst/>
-          </a:prstGeom>
-          <a:noFill/>
-          <a:ln>
-            <a:noFill/>
-          </a:ln>
-        </p:spPr>
-        <p:txBody>
-          <a:bodyPr anchorCtr="0" anchor="ctr" bIns="0" lIns="0" spcFirstLastPara="1" rIns="0" wrap="square" tIns="0">
-            <a:noAutofit/>
-          </a:bodyPr>
-          <a:lstStyle/>
-          <a:p>
-            <a:pPr indent="0" lvl="0" marL="0" marR="0" rtl="0" algn="ctr">
-              <a:spcBef>
-                <a:spcPts val="0"/>
-              </a:spcBef>
-              <a:spcAft>
-                <a:spcPts val="0"/>
-              </a:spcAft>
-              <a:buClr>
-                <a:srgbClr val="64748B"/>
-              </a:buClr>
-              <a:buSzPts val="1200"/>
-              <a:buFont typeface="Calibri"/>
-              <a:buNone/>
-            </a:pPr>
-            <a:r>
-              <a:rPr b="0" i="0" lang="en-US" sz="1200" u="none" cap="none" strike="noStrike">
-                <a:solidFill>
-                  <a:srgbClr val="64748B"/>
+                  <a:schemeClr val="lt1"/>
                 </a:solidFill>
                 <a:latin typeface="Calibri"/>
                 <a:ea typeface="Calibri"/>
                 <a:cs typeface="Calibri"/>
                 <a:sym typeface="Calibri"/>
               </a:rPr>
-              <a:t>Avg Reward</a:t>
+              <a:t>only</a:t>
             </a:r>
-            <a:endParaRPr b="0" i="0" sz="1200" u="none" cap="none" strike="noStrike">
-              <a:solidFill>
-                <a:schemeClr val="dk1"/>
-              </a:solidFill>
-              <a:latin typeface="Calibri"/>
-              <a:ea typeface="Calibri"/>
-              <a:cs typeface="Calibri"/>
-              <a:sym typeface="Calibri"/>
-            </a:endParaRPr>
-          </a:p>
-        </p:txBody>
-      </p:sp>
-      <p:sp>
-        <p:nvSpPr>
-          <p:cNvPr id="101" name="Google Shape;101;g395f996db06_0_0"/>
-          <p:cNvSpPr/>
-          <p:nvPr/>
-        </p:nvSpPr>
-        <p:spPr>
-          <a:xfrm>
-            <a:off x="457200" y="3017520"/>
-            <a:ext cx="7315200" cy="365700"/>
-          </a:xfrm>
-          <a:prstGeom prst="rect">
-            <a:avLst/>
-          </a:prstGeom>
-          <a:noFill/>
-          <a:ln>
-            <a:noFill/>
-          </a:ln>
-        </p:spPr>
-        <p:txBody>
-          <a:bodyPr anchorCtr="0" anchor="ctr" bIns="45700" lIns="91425" spcFirstLastPara="1" rIns="91425" wrap="square" tIns="45700">
-            <a:noAutofit/>
-          </a:bodyPr>
-          <a:lstStyle/>
-          <a:p>
-            <a:pPr indent="0" lvl="0" marL="0" marR="0" rtl="0" algn="l">
-              <a:spcBef>
-                <a:spcPts val="0"/>
-              </a:spcBef>
-              <a:spcAft>
-                <a:spcPts val="0"/>
-              </a:spcAft>
-              <a:buClr>
-                <a:srgbClr val="64748B"/>
-              </a:buClr>
-              <a:buSzPts val="1100"/>
-              <a:buFont typeface="Calibri"/>
-              <a:buNone/>
-            </a:pPr>
             <a:r>
-              <a:rPr b="0" i="1" lang="en-US" sz="1100" u="none" cap="none" strike="noStrike">
+              <a:rPr lang="en-US" sz="1600">
                 <a:solidFill>
-                  <a:srgbClr val="64748B"/>
+                  <a:schemeClr val="lt1"/>
                 </a:solidFill>
                 <a:latin typeface="Calibri"/>
                 <a:ea typeface="Calibri"/>
                 <a:cs typeface="Calibri"/>
                 <a:sym typeface="Calibri"/>
               </a:rPr>
-              <a:t>Evaluated over 1,000 episodes using best model checkpoint.</a:t>
+              <a:t> change customer_exit_threshold from the gym environment (from 5) to 7.</a:t>
             </a:r>
-            <a:endParaRPr b="0" i="0" sz="1100" u="none" cap="none" strike="noStrike">
+            <a:endParaRPr sz="1600">
               <a:solidFill>
-                <a:schemeClr val="dk1"/>
-              </a:solidFill>
-              <a:latin typeface="Calibri"/>
-              <a:ea typeface="Calibri"/>
-              <a:cs typeface="Calibri"/>
-              <a:sym typeface="Calibri"/>
-            </a:endParaRPr>
-          </a:p>
-        </p:txBody>
-      </p:sp>
-      <p:sp>
-        <p:nvSpPr>
-          <p:cNvPr id="102" name="Google Shape;102;g395f996db06_0_0"/>
-          <p:cNvSpPr/>
-          <p:nvPr/>
-        </p:nvSpPr>
-        <p:spPr>
-          <a:xfrm>
-            <a:off x="457200" y="4663440"/>
-            <a:ext cx="8229600" cy="365700"/>
-          </a:xfrm>
-          <a:prstGeom prst="rect">
-            <a:avLst/>
-          </a:prstGeom>
-          <a:noFill/>
-          <a:ln>
-            <a:noFill/>
-          </a:ln>
-        </p:spPr>
-        <p:txBody>
-          <a:bodyPr anchorCtr="0" anchor="ctr" bIns="45700" lIns="91425" spcFirstLastPara="1" rIns="91425" wrap="square" tIns="45700">
-            <a:noAutofit/>
-          </a:bodyPr>
-          <a:lstStyle/>
-          <a:p>
-            <a:pPr indent="0" lvl="0" marL="0" marR="0" rtl="0" algn="l">
-              <a:spcBef>
-                <a:spcPts val="0"/>
-              </a:spcBef>
-              <a:spcAft>
-                <a:spcPts val="0"/>
-              </a:spcAft>
-              <a:buClr>
-                <a:srgbClr val="64748B"/>
-              </a:buClr>
-              <a:buSzPts val="900"/>
-              <a:buFont typeface="Calibri"/>
-              <a:buNone/>
-            </a:pPr>
-            <a:r>
-              <a:rPr b="0" i="0" lang="en-US" sz="900" u="none" cap="none" strike="noStrike">
-                <a:solidFill>
-                  <a:srgbClr val="64748B"/>
-                </a:solidFill>
-                <a:latin typeface="Calibri"/>
-                <a:ea typeface="Calibri"/>
-                <a:cs typeface="Calibri"/>
-                <a:sym typeface="Calibri"/>
-              </a:rPr>
-              <a:t>DQN Evaluation Results</a:t>
-            </a:r>
-            <a:endParaRPr b="0" i="0" sz="900" u="none" cap="none" strike="noStrike">
-              <a:solidFill>
-                <a:schemeClr val="dk1"/>
-              </a:solidFill>
-              <a:latin typeface="Calibri"/>
-              <a:ea typeface="Calibri"/>
-              <a:cs typeface="Calibri"/>
-              <a:sym typeface="Calibri"/>
-            </a:endParaRPr>
-          </a:p>
-        </p:txBody>
-      </p:sp>
-      <p:sp>
-        <p:nvSpPr>
-          <p:cNvPr id="103" name="Google Shape;103;g395f996db06_0_0"/>
-          <p:cNvSpPr/>
-          <p:nvPr/>
-        </p:nvSpPr>
-        <p:spPr>
-          <a:xfrm>
-            <a:off x="6126492" y="1188720"/>
-            <a:ext cx="2560200" cy="1463100"/>
-          </a:xfrm>
-          <a:prstGeom prst="rect">
-            <a:avLst/>
-          </a:prstGeom>
-          <a:solidFill>
-            <a:srgbClr val="FFFFFF"/>
-          </a:solidFill>
-          <a:ln>
-            <a:noFill/>
-          </a:ln>
-          <a:effectLst>
-            <a:outerShdw blurRad="76200" rotWithShape="0" algn="bl" dir="8100000" dist="25400">
-              <a:srgbClr val="000000">
-                <a:alpha val="7840"/>
-              </a:srgbClr>
-            </a:outerShdw>
-          </a:effectLst>
-        </p:spPr>
-        <p:txBody>
-          <a:bodyPr anchorCtr="0" anchor="ctr" bIns="91425" lIns="91425" spcFirstLastPara="1" rIns="91425" wrap="square" tIns="91425">
-            <a:noAutofit/>
-          </a:bodyPr>
-          <a:lstStyle/>
-          <a:p>
-            <a:pPr indent="0" lvl="0" marL="0" rtl="0" algn="l">
-              <a:spcBef>
-                <a:spcPts val="0"/>
-              </a:spcBef>
-              <a:spcAft>
-                <a:spcPts val="0"/>
-              </a:spcAft>
-              <a:buNone/>
-            </a:pPr>
-            <a:r>
-              <a:t/>
-            </a:r>
-            <a:endParaRPr/>
-          </a:p>
-        </p:txBody>
-      </p:sp>
-      <p:sp>
-        <p:nvSpPr>
-          <p:cNvPr id="104" name="Google Shape;104;g395f996db06_0_0"/>
-          <p:cNvSpPr/>
-          <p:nvPr/>
-        </p:nvSpPr>
-        <p:spPr>
-          <a:xfrm>
-            <a:off x="6126492" y="1325880"/>
-            <a:ext cx="2560200" cy="822900"/>
-          </a:xfrm>
-          <a:prstGeom prst="rect">
-            <a:avLst/>
-          </a:prstGeom>
-          <a:noFill/>
-          <a:ln>
-            <a:noFill/>
-          </a:ln>
-        </p:spPr>
-        <p:txBody>
-          <a:bodyPr anchorCtr="0" anchor="ctr" bIns="0" lIns="0" spcFirstLastPara="1" rIns="0" wrap="square" tIns="0">
-            <a:noAutofit/>
-          </a:bodyPr>
-          <a:lstStyle/>
-          <a:p>
-            <a:pPr indent="0" lvl="0" marL="0" marR="0" rtl="0" algn="ctr">
-              <a:spcBef>
-                <a:spcPts val="0"/>
-              </a:spcBef>
-              <a:spcAft>
-                <a:spcPts val="0"/>
-              </a:spcAft>
-              <a:buClr>
-                <a:srgbClr val="0891B2"/>
-              </a:buClr>
-              <a:buSzPts val="4400"/>
-              <a:buFont typeface="Trebuchet MS"/>
-              <a:buNone/>
-            </a:pPr>
-            <a:r>
-              <a:rPr b="1" lang="en-US" sz="4400">
-                <a:solidFill>
-                  <a:srgbClr val="0891B2"/>
-                </a:solidFill>
-                <a:latin typeface="Trebuchet MS"/>
-                <a:ea typeface="Trebuchet MS"/>
-                <a:cs typeface="Trebuchet MS"/>
-                <a:sym typeface="Trebuchet MS"/>
-              </a:rPr>
-              <a:t>4.5</a:t>
-            </a:r>
-            <a:endParaRPr b="0" i="0" sz="4400" u="none" cap="none" strike="noStrike">
-              <a:solidFill>
-                <a:schemeClr val="dk1"/>
-              </a:solidFill>
-              <a:latin typeface="Calibri"/>
-              <a:ea typeface="Calibri"/>
-              <a:cs typeface="Calibri"/>
-              <a:sym typeface="Calibri"/>
-            </a:endParaRPr>
-          </a:p>
-        </p:txBody>
-      </p:sp>
-      <p:sp>
-        <p:nvSpPr>
-          <p:cNvPr id="105" name="Google Shape;105;g395f996db06_0_0"/>
-          <p:cNvSpPr/>
-          <p:nvPr/>
-        </p:nvSpPr>
-        <p:spPr>
-          <a:xfrm>
-            <a:off x="6126492" y="2148840"/>
-            <a:ext cx="2560200" cy="365700"/>
-          </a:xfrm>
-          <a:prstGeom prst="rect">
-            <a:avLst/>
-          </a:prstGeom>
-          <a:noFill/>
-          <a:ln>
-            <a:noFill/>
-          </a:ln>
-        </p:spPr>
-        <p:txBody>
-          <a:bodyPr anchorCtr="0" anchor="ctr" bIns="0" lIns="0" spcFirstLastPara="1" rIns="0" wrap="square" tIns="0">
-            <a:noAutofit/>
-          </a:bodyPr>
-          <a:lstStyle/>
-          <a:p>
-            <a:pPr indent="0" lvl="0" marL="0" marR="0" rtl="0" algn="ctr">
-              <a:spcBef>
-                <a:spcPts val="0"/>
-              </a:spcBef>
-              <a:spcAft>
-                <a:spcPts val="0"/>
-              </a:spcAft>
-              <a:buClr>
-                <a:srgbClr val="64748B"/>
-              </a:buClr>
-              <a:buSzPts val="1200"/>
-              <a:buFont typeface="Calibri"/>
-              <a:buNone/>
-            </a:pPr>
-            <a:r>
-              <a:rPr b="0" i="0" lang="en-US" sz="1200" u="none" cap="none" strike="noStrike">
-                <a:solidFill>
-                  <a:srgbClr val="64748B"/>
-                </a:solidFill>
-                <a:latin typeface="Calibri"/>
-                <a:ea typeface="Calibri"/>
-                <a:cs typeface="Calibri"/>
-                <a:sym typeface="Calibri"/>
-              </a:rPr>
-              <a:t>Avg </a:t>
-            </a:r>
-            <a:r>
-              <a:rPr lang="en-US" sz="1200">
-                <a:solidFill>
-                  <a:srgbClr val="64748B"/>
-                </a:solidFill>
-                <a:latin typeface="Calibri"/>
-                <a:ea typeface="Calibri"/>
-                <a:cs typeface="Calibri"/>
-                <a:sym typeface="Calibri"/>
-              </a:rPr>
-              <a:t>Round</a:t>
-            </a:r>
-            <a:endParaRPr b="0" i="0" sz="1200" u="none" cap="none" strike="noStrike">
-              <a:solidFill>
-                <a:schemeClr val="dk1"/>
+                <a:schemeClr val="lt1"/>
               </a:solidFill>
               <a:latin typeface="Calibri"/>
               <a:ea typeface="Calibri"/>

</xml_diff>